<commit_message>
Final visual QA pass: fix low-contrast labels and remove banned hub-and-satellite composition
- Fix "SITUACIÓN" label contrast in scenario/case cards: several blue-family
  chapter accents (steelBlue, cobalt, deepBlue, tealBlue) read as washed-out
  directly on the navy card background; now lightened via blend() so the
  label stays legible regardless of which chapter accent is active.
- Replace the Tema 7 radial diagram (central circle with orbiting satellite
  icons) with a role-band layout (banner + row of role cards), since it
  reproduced the central-hub composition explicitly rejected for this deck.
- Full slide-by-slide review of all 47 slides confirms legible text,
  consistent icon styling, and no overlapping or overflowing content.

Co-Authored-By: Claude Sonnet 5 <noreply@anthropic.com>
Claude-Session: https://claude.ai/code/session_01VbDBTsyG5QwHCNDLUQQk1r
</commit_message>
<xml_diff>
--- a/capacitacion-riesgos-2025/CAPACITACION_RIESGOS_2025.pptx
+++ b/capacitacion-riesgos-2025/CAPACITACION_RIESGOS_2025.pptx
@@ -2572,7 +2572,7 @@
           <a:p>
             <a:r>
               <a:rPr lang="en-US" dirty="0"/>
-              <a:t>Recorre cada rol alrededor de "TODOS" con una frase corta sobre su función. No te extiendas demasiado en ninguno: el punto es que el grupo se vea reflejado en el centro del diagrama.</a:t>
+              <a:t>Recorre cada rol de izquierda a derecha con una frase corta sobre su función. No te extiendas demasiado en ninguno: el punto es que todos los roles se vean bajo el mismo mensaje de "todos somos responsables".</a:t>
             </a:r>
             <a:endParaRPr lang="en-US" dirty="0"/>
           </a:p>
@@ -5659,7 +5659,7 @@
             <a:r>
               <a:rPr lang="en-US" sz="1200" b="1" spc="200" kern="0" dirty="0">
                 <a:solidFill>
-                  <a:srgbClr val="2E86C7"/>
+                  <a:srgbClr val="A1C9E6"/>
                 </a:solidFill>
                 <a:latin typeface="Calibri" pitchFamily="34" charset="0"/>
                 <a:ea typeface="Calibri" pitchFamily="34" charset="-122"/>
@@ -10282,7 +10282,7 @@
             <a:r>
               <a:rPr lang="en-US" sz="1200" b="1" spc="200" kern="0" dirty="0">
                 <a:solidFill>
-                  <a:srgbClr val="3A6EA5"/>
+                  <a:srgbClr val="A6BED7"/>
                 </a:solidFill>
                 <a:latin typeface="Calibri" pitchFamily="34" charset="0"/>
                 <a:ea typeface="Calibri" pitchFamily="34" charset="-122"/>
@@ -20767,44 +20767,59 @@
           <p:nvPr/>
         </p:nvSpPr>
         <p:spPr>
-          <a:xfrm flipV="1">
-            <a:off x="6095848" y="2304288"/>
-            <a:ext cx="9144" cy="1600200"/>
-          </a:xfrm>
-          <a:prstGeom prst="line">
-            <a:avLst/>
-          </a:prstGeom>
-          <a:noFill/>
-          <a:ln w="19050">
-            <a:solidFill>
-              <a:srgbClr val="E3E8EF"/>
-            </a:solidFill>
-            <a:prstDash val="solid"/>
-          </a:ln>
-        </p:spPr>
-      </p:sp>
-      <p:sp>
-        <p:nvSpPr>
-          <p:cNvPr id="6" name="Shape 3"/>
-          <p:cNvSpPr/>
-          <p:nvPr/>
-        </p:nvSpPr>
-        <p:spPr>
-          <a:xfrm flipV="1">
-            <a:off x="6095848" y="3409999"/>
-            <a:ext cx="1521881" cy="494489"/>
-          </a:xfrm>
-          <a:prstGeom prst="line">
-            <a:avLst/>
-          </a:prstGeom>
-          <a:noFill/>
-          <a:ln w="19050">
-            <a:solidFill>
-              <a:srgbClr val="E3E8EF"/>
-            </a:solidFill>
-            <a:prstDash val="solid"/>
-          </a:ln>
-        </p:spPr>
+          <a:xfrm>
+            <a:off x="566928" y="1965960"/>
+            <a:ext cx="11057839" cy="566928"/>
+          </a:xfrm>
+          <a:prstGeom prst="roundRect">
+            <a:avLst>
+              <a:gd name="adj" fmla="val 16129"/>
+            </a:avLst>
+          </a:prstGeom>
+          <a:solidFill>
+            <a:srgbClr val="1FB6C9"/>
+          </a:solidFill>
+          <a:ln/>
+        </p:spPr>
+      </p:sp>
+      <p:sp>
+        <p:nvSpPr>
+          <p:cNvPr id="6" name="Text 3"/>
+          <p:cNvSpPr txBox="1"/>
+          <p:nvPr/>
+        </p:nvSpPr>
+        <p:spPr>
+          <a:xfrm>
+            <a:off x="566928" y="1965960"/>
+            <a:ext cx="11057839" cy="566928"/>
+          </a:xfrm>
+          <a:prstGeom prst="rect">
+            <a:avLst/>
+          </a:prstGeom>
+          <a:noFill/>
+          <a:ln/>
+        </p:spPr>
+        <p:txBody>
+          <a:bodyPr wrap="square" lIns="0" tIns="0" rIns="0" bIns="0" rtlCol="0" anchor="ctr"/>
+          <a:lstStyle/>
+          <a:p>
+            <a:pPr algn="ctr" indent="0" marL="0">
+              <a:buNone/>
+            </a:pPr>
+            <a:r>
+              <a:rPr lang="en-US" sz="1900" b="1" spc="300" kern="0" dirty="0">
+                <a:solidFill>
+                  <a:srgbClr val="FFFFFF"/>
+                </a:solidFill>
+                <a:latin typeface="Cambria" pitchFamily="34" charset="0"/>
+                <a:ea typeface="Cambria" pitchFamily="34" charset="-122"/>
+                <a:cs typeface="Cambria" pitchFamily="34" charset="-120"/>
+              </a:rPr>
+              <a:t>TODOS SOMOS RESPONSABLES</a:t>
+            </a:r>
+            <a:endParaRPr lang="en-US" sz="1900" dirty="0"/>
+          </a:p>
+        </p:txBody>
       </p:sp>
       <p:sp>
         <p:nvSpPr>
@@ -20814,77 +20829,8 @@
         </p:nvSpPr>
         <p:spPr>
           <a:xfrm>
-            <a:off x="6095848" y="3904488"/>
-            <a:ext cx="940574" cy="1294589"/>
-          </a:xfrm>
-          <a:prstGeom prst="line">
-            <a:avLst/>
-          </a:prstGeom>
-          <a:noFill/>
-          <a:ln w="19050">
-            <a:solidFill>
-              <a:srgbClr val="E3E8EF"/>
-            </a:solidFill>
-            <a:prstDash val="solid"/>
-          </a:ln>
-        </p:spPr>
-      </p:sp>
-      <p:sp>
-        <p:nvSpPr>
-          <p:cNvPr id="8" name="Shape 5"/>
-          <p:cNvSpPr/>
-          <p:nvPr/>
-        </p:nvSpPr>
-        <p:spPr>
-          <a:xfrm flipH="1">
-            <a:off x="5155274" y="3904488"/>
-            <a:ext cx="940574" cy="1294589"/>
-          </a:xfrm>
-          <a:prstGeom prst="line">
-            <a:avLst/>
-          </a:prstGeom>
-          <a:noFill/>
-          <a:ln w="19050">
-            <a:solidFill>
-              <a:srgbClr val="E3E8EF"/>
-            </a:solidFill>
-            <a:prstDash val="solid"/>
-          </a:ln>
-        </p:spPr>
-      </p:sp>
-      <p:sp>
-        <p:nvSpPr>
-          <p:cNvPr id="9" name="Shape 6"/>
-          <p:cNvSpPr/>
-          <p:nvPr/>
-        </p:nvSpPr>
-        <p:spPr>
-          <a:xfrm flipH="1" flipV="1">
-            <a:off x="4573967" y="3409999"/>
-            <a:ext cx="1521881" cy="494489"/>
-          </a:xfrm>
-          <a:prstGeom prst="line">
-            <a:avLst/>
-          </a:prstGeom>
-          <a:noFill/>
-          <a:ln w="19050">
-            <a:solidFill>
-              <a:srgbClr val="E3E8EF"/>
-            </a:solidFill>
-            <a:prstDash val="solid"/>
-          </a:ln>
-        </p:spPr>
-      </p:sp>
-      <p:sp>
-        <p:nvSpPr>
-          <p:cNvPr id="10" name="Shape 7"/>
-          <p:cNvSpPr/>
-          <p:nvPr/>
-        </p:nvSpPr>
-        <p:spPr>
-          <a:xfrm>
-            <a:off x="5707228" y="1915668"/>
-            <a:ext cx="777240" cy="777240"/>
+            <a:off x="1213683" y="3680460"/>
+            <a:ext cx="713232" cy="713232"/>
           </a:xfrm>
           <a:prstGeom prst="ellipse">
             <a:avLst/>
@@ -20897,7 +20843,7 @@
       </p:sp>
       <p:pic>
         <p:nvPicPr>
-          <p:cNvPr id="11" name="Image 0" descr="/tmp/claude-0/-home-user-riesgo/0ff9ff46-1396-5bd8-b3ac-2280dfbbbc55/scratchpad/work/gen/icons/person_white.png">    </p:cNvPr>
+          <p:cNvPr id="8" name="Image 0" descr="/tmp/claude-0/-home-user-riesgo/0ff9ff46-1396-5bd8-b3ac-2280dfbbbc55/scratchpad/work/gen/icons/person_white.png">    </p:cNvPr>
           <p:cNvPicPr>
             <a:picLocks noChangeAspect="1"/>
           </p:cNvPicPr>
@@ -20911,8 +20857,8 @@
         </p:blipFill>
         <p:spPr>
           <a:xfrm>
-            <a:off x="5901538" y="2109978"/>
-            <a:ext cx="388620" cy="388620"/>
+            <a:off x="1391991" y="3858768"/>
+            <a:ext cx="356616" cy="356616"/>
           </a:xfrm>
           <a:prstGeom prst="rect">
             <a:avLst/>
@@ -20921,14 +20867,14 @@
       </p:pic>
       <p:sp>
         <p:nvSpPr>
-          <p:cNvPr id="12" name="Text 8"/>
-          <p:cNvSpPr txBox="1"/>
-          <p:nvPr/>
-        </p:nvSpPr>
-        <p:spPr>
-          <a:xfrm>
-            <a:off x="5227168" y="2775204"/>
-            <a:ext cx="1737360" cy="457200"/>
+          <p:cNvPr id="9" name="Text 5"/>
+          <p:cNvSpPr txBox="1"/>
+          <p:nvPr/>
+        </p:nvSpPr>
+        <p:spPr>
+          <a:xfrm>
+            <a:off x="612648" y="4539996"/>
+            <a:ext cx="1915302" cy="548640"/>
           </a:xfrm>
           <a:prstGeom prst="rect">
             <a:avLst/>
@@ -20942,7 +20888,7 @@
           <a:p>
             <a:pPr algn="ctr" indent="0" marL="0">
               <a:lnSpc>
-                <a:spcPct val="95000"/>
+                <a:spcPct val="98000"/>
               </a:lnSpc>
               <a:buNone/>
             </a:pPr>
@@ -20963,14 +20909,14 @@
       </p:sp>
       <p:sp>
         <p:nvSpPr>
-          <p:cNvPr id="13" name="Shape 9"/>
+          <p:cNvPr id="10" name="Shape 6"/>
           <p:cNvSpPr/>
           <p:nvPr/>
         </p:nvSpPr>
         <p:spPr>
           <a:xfrm>
-            <a:off x="7229108" y="3021379"/>
-            <a:ext cx="777240" cy="777240"/>
+            <a:off x="3476457" y="3680460"/>
+            <a:ext cx="713232" cy="713232"/>
           </a:xfrm>
           <a:prstGeom prst="ellipse">
             <a:avLst/>
@@ -20983,7 +20929,7 @@
       </p:sp>
       <p:pic>
         <p:nvPicPr>
-          <p:cNvPr id="14" name="Image 1" descr="/tmp/claude-0/-home-user-riesgo/0ff9ff46-1396-5bd8-b3ac-2280dfbbbc55/scratchpad/work/gen/icons/briefcase_white.png">    </p:cNvPr>
+          <p:cNvPr id="11" name="Image 1" descr="/tmp/claude-0/-home-user-riesgo/0ff9ff46-1396-5bd8-b3ac-2280dfbbbc55/scratchpad/work/gen/icons/briefcase_white.png">    </p:cNvPr>
           <p:cNvPicPr>
             <a:picLocks noChangeAspect="1"/>
           </p:cNvPicPr>
@@ -20997,8 +20943,8 @@
         </p:blipFill>
         <p:spPr>
           <a:xfrm>
-            <a:off x="7423418" y="3215689"/>
-            <a:ext cx="388620" cy="388620"/>
+            <a:off x="3654765" y="3858768"/>
+            <a:ext cx="356616" cy="356616"/>
           </a:xfrm>
           <a:prstGeom prst="rect">
             <a:avLst/>
@@ -21007,14 +20953,14 @@
       </p:pic>
       <p:sp>
         <p:nvSpPr>
-          <p:cNvPr id="15" name="Text 10"/>
-          <p:cNvSpPr txBox="1"/>
-          <p:nvPr/>
-        </p:nvSpPr>
-        <p:spPr>
-          <a:xfrm>
-            <a:off x="6749048" y="3880915"/>
-            <a:ext cx="1737360" cy="457200"/>
+          <p:cNvPr id="12" name="Text 7"/>
+          <p:cNvSpPr txBox="1"/>
+          <p:nvPr/>
+        </p:nvSpPr>
+        <p:spPr>
+          <a:xfrm>
+            <a:off x="2875422" y="4539996"/>
+            <a:ext cx="1915302" cy="548640"/>
           </a:xfrm>
           <a:prstGeom prst="rect">
             <a:avLst/>
@@ -21028,7 +20974,7 @@
           <a:p>
             <a:pPr algn="ctr" indent="0" marL="0">
               <a:lnSpc>
-                <a:spcPct val="95000"/>
+                <a:spcPct val="98000"/>
               </a:lnSpc>
               <a:buNone/>
             </a:pPr>
@@ -21049,14 +20995,14 @@
       </p:sp>
       <p:sp>
         <p:nvSpPr>
-          <p:cNvPr id="16" name="Shape 11"/>
+          <p:cNvPr id="13" name="Shape 8"/>
           <p:cNvSpPr/>
           <p:nvPr/>
         </p:nvSpPr>
         <p:spPr>
           <a:xfrm>
-            <a:off x="6647802" y="4810457"/>
-            <a:ext cx="777240" cy="777240"/>
+            <a:off x="5739232" y="3680460"/>
+            <a:ext cx="713232" cy="713232"/>
           </a:xfrm>
           <a:prstGeom prst="ellipse">
             <a:avLst/>
@@ -21069,7 +21015,7 @@
       </p:sp>
       <p:pic>
         <p:nvPicPr>
-          <p:cNvPr id="17" name="Image 2" descr="/tmp/claude-0/-home-user-riesgo/0ff9ff46-1396-5bd8-b3ac-2280dfbbbc55/scratchpad/work/gen/icons/crown_white.png">    </p:cNvPr>
+          <p:cNvPr id="14" name="Image 2" descr="/tmp/claude-0/-home-user-riesgo/0ff9ff46-1396-5bd8-b3ac-2280dfbbbc55/scratchpad/work/gen/icons/crown_white.png">    </p:cNvPr>
           <p:cNvPicPr>
             <a:picLocks noChangeAspect="1"/>
           </p:cNvPicPr>
@@ -21083,8 +21029,8 @@
         </p:blipFill>
         <p:spPr>
           <a:xfrm>
-            <a:off x="6842112" y="5004767"/>
-            <a:ext cx="388620" cy="388620"/>
+            <a:off x="5917540" y="3858768"/>
+            <a:ext cx="356616" cy="356616"/>
           </a:xfrm>
           <a:prstGeom prst="rect">
             <a:avLst/>
@@ -21093,14 +21039,14 @@
       </p:pic>
       <p:sp>
         <p:nvSpPr>
-          <p:cNvPr id="18" name="Text 12"/>
-          <p:cNvSpPr txBox="1"/>
-          <p:nvPr/>
-        </p:nvSpPr>
-        <p:spPr>
-          <a:xfrm>
-            <a:off x="6167742" y="5669993"/>
-            <a:ext cx="1737360" cy="457200"/>
+          <p:cNvPr id="15" name="Text 9"/>
+          <p:cNvSpPr txBox="1"/>
+          <p:nvPr/>
+        </p:nvSpPr>
+        <p:spPr>
+          <a:xfrm>
+            <a:off x="5138196" y="4539996"/>
+            <a:ext cx="1915302" cy="548640"/>
           </a:xfrm>
           <a:prstGeom prst="rect">
             <a:avLst/>
@@ -21114,7 +21060,7 @@
           <a:p>
             <a:pPr algn="ctr" indent="0" marL="0">
               <a:lnSpc>
-                <a:spcPct val="95000"/>
+                <a:spcPct val="98000"/>
               </a:lnSpc>
               <a:buNone/>
             </a:pPr>
@@ -21135,14 +21081,14 @@
       </p:sp>
       <p:sp>
         <p:nvSpPr>
-          <p:cNvPr id="19" name="Shape 13"/>
+          <p:cNvPr id="16" name="Shape 10"/>
           <p:cNvSpPr/>
           <p:nvPr/>
         </p:nvSpPr>
         <p:spPr>
           <a:xfrm>
-            <a:off x="4766654" y="4810457"/>
-            <a:ext cx="777240" cy="777240"/>
+            <a:off x="8002006" y="3680460"/>
+            <a:ext cx="713232" cy="713232"/>
           </a:xfrm>
           <a:prstGeom prst="ellipse">
             <a:avLst/>
@@ -21155,7 +21101,7 @@
       </p:sp>
       <p:pic>
         <p:nvPicPr>
-          <p:cNvPr id="20" name="Image 3" descr="/tmp/claude-0/-home-user-riesgo/0ff9ff46-1396-5bd8-b3ac-2280dfbbbc55/scratchpad/work/gen/icons/shield_check_white.png">    </p:cNvPr>
+          <p:cNvPr id="17" name="Image 3" descr="/tmp/claude-0/-home-user-riesgo/0ff9ff46-1396-5bd8-b3ac-2280dfbbbc55/scratchpad/work/gen/icons/shield_check_white.png">    </p:cNvPr>
           <p:cNvPicPr>
             <a:picLocks noChangeAspect="1"/>
           </p:cNvPicPr>
@@ -21169,8 +21115,8 @@
         </p:blipFill>
         <p:spPr>
           <a:xfrm>
-            <a:off x="4960964" y="5004767"/>
-            <a:ext cx="388620" cy="388620"/>
+            <a:off x="8180314" y="3858768"/>
+            <a:ext cx="356616" cy="356616"/>
           </a:xfrm>
           <a:prstGeom prst="rect">
             <a:avLst/>
@@ -21179,14 +21125,14 @@
       </p:pic>
       <p:sp>
         <p:nvSpPr>
-          <p:cNvPr id="21" name="Text 14"/>
-          <p:cNvSpPr txBox="1"/>
-          <p:nvPr/>
-        </p:nvSpPr>
-        <p:spPr>
-          <a:xfrm>
-            <a:off x="4286594" y="5669993"/>
-            <a:ext cx="1737360" cy="457200"/>
+          <p:cNvPr id="18" name="Text 11"/>
+          <p:cNvSpPr txBox="1"/>
+          <p:nvPr/>
+        </p:nvSpPr>
+        <p:spPr>
+          <a:xfrm>
+            <a:off x="7400971" y="4539996"/>
+            <a:ext cx="1915302" cy="548640"/>
           </a:xfrm>
           <a:prstGeom prst="rect">
             <a:avLst/>
@@ -21200,7 +21146,7 @@
           <a:p>
             <a:pPr algn="ctr" indent="0" marL="0">
               <a:lnSpc>
-                <a:spcPct val="95000"/>
+                <a:spcPct val="98000"/>
               </a:lnSpc>
               <a:buNone/>
             </a:pPr>
@@ -21221,14 +21167,14 @@
       </p:sp>
       <p:sp>
         <p:nvSpPr>
-          <p:cNvPr id="22" name="Shape 15"/>
+          <p:cNvPr id="19" name="Shape 12"/>
           <p:cNvSpPr/>
           <p:nvPr/>
         </p:nvSpPr>
         <p:spPr>
           <a:xfrm>
-            <a:off x="4185347" y="3021379"/>
-            <a:ext cx="777240" cy="777240"/>
+            <a:off x="10264780" y="3680460"/>
+            <a:ext cx="713232" cy="713232"/>
           </a:xfrm>
           <a:prstGeom prst="ellipse">
             <a:avLst/>
@@ -21241,7 +21187,7 @@
       </p:sp>
       <p:pic>
         <p:nvPicPr>
-          <p:cNvPr id="23" name="Image 4" descr="/tmp/claude-0/-home-user-riesgo/0ff9ff46-1396-5bd8-b3ac-2280dfbbbc55/scratchpad/work/gen/icons/clipboard_check_white.png">    </p:cNvPr>
+          <p:cNvPr id="20" name="Image 4" descr="/tmp/claude-0/-home-user-riesgo/0ff9ff46-1396-5bd8-b3ac-2280dfbbbc55/scratchpad/work/gen/icons/clipboard_check_white.png">    </p:cNvPr>
           <p:cNvPicPr>
             <a:picLocks noChangeAspect="1"/>
           </p:cNvPicPr>
@@ -21255,8 +21201,8 @@
         </p:blipFill>
         <p:spPr>
           <a:xfrm>
-            <a:off x="4379657" y="3215689"/>
-            <a:ext cx="388620" cy="388620"/>
+            <a:off x="10443088" y="3858768"/>
+            <a:ext cx="356616" cy="356616"/>
           </a:xfrm>
           <a:prstGeom prst="rect">
             <a:avLst/>
@@ -21265,14 +21211,14 @@
       </p:pic>
       <p:sp>
         <p:nvSpPr>
-          <p:cNvPr id="24" name="Text 16"/>
-          <p:cNvSpPr txBox="1"/>
-          <p:nvPr/>
-        </p:nvSpPr>
-        <p:spPr>
-          <a:xfrm>
-            <a:off x="3705287" y="3880915"/>
-            <a:ext cx="1737360" cy="457200"/>
+          <p:cNvPr id="21" name="Text 13"/>
+          <p:cNvSpPr txBox="1"/>
+          <p:nvPr/>
+        </p:nvSpPr>
+        <p:spPr>
+          <a:xfrm>
+            <a:off x="9663745" y="4539996"/>
+            <a:ext cx="1915302" cy="548640"/>
           </a:xfrm>
           <a:prstGeom prst="rect">
             <a:avLst/>
@@ -21286,7 +21232,7 @@
           <a:p>
             <a:pPr algn="ctr" indent="0" marL="0">
               <a:lnSpc>
-                <a:spcPct val="95000"/>
+                <a:spcPct val="98000"/>
               </a:lnSpc>
               <a:buNone/>
             </a:pPr>
@@ -21307,73 +21253,7 @@
       </p:sp>
       <p:sp>
         <p:nvSpPr>
-          <p:cNvPr id="25" name="Shape 17"/>
-          <p:cNvSpPr/>
-          <p:nvPr/>
-        </p:nvSpPr>
-        <p:spPr>
-          <a:xfrm>
-            <a:off x="5432908" y="3241548"/>
-            <a:ext cx="1325880" cy="1325880"/>
-          </a:xfrm>
-          <a:prstGeom prst="ellipse">
-            <a:avLst/>
-          </a:prstGeom>
-          <a:solidFill>
-            <a:srgbClr val="1FB6C9"/>
-          </a:solidFill>
-          <a:ln/>
-          <a:effectLst>
-            <a:outerShdw sx="100000" sy="100000" kx="0" ky="0" algn="bl" rotWithShape="0" blurRad="127000" dist="38100" dir="5400000">
-              <a:srgbClr val="17223A">
-                <a:alpha val="18000"/>
-              </a:srgbClr>
-            </a:outerShdw>
-          </a:effectLst>
-        </p:spPr>
-      </p:sp>
-      <p:sp>
-        <p:nvSpPr>
-          <p:cNvPr id="26" name="Text 18"/>
-          <p:cNvSpPr txBox="1"/>
-          <p:nvPr/>
-        </p:nvSpPr>
-        <p:spPr>
-          <a:xfrm>
-            <a:off x="5432908" y="3648456"/>
-            <a:ext cx="1325880" cy="512064"/>
-          </a:xfrm>
-          <a:prstGeom prst="rect">
-            <a:avLst/>
-          </a:prstGeom>
-          <a:noFill/>
-          <a:ln/>
-        </p:spPr>
-        <p:txBody>
-          <a:bodyPr wrap="square" lIns="0" tIns="0" rIns="0" bIns="0" rtlCol="0" anchor="ctr"/>
-          <a:lstStyle/>
-          <a:p>
-            <a:pPr algn="ctr" indent="0" marL="0">
-              <a:buNone/>
-            </a:pPr>
-            <a:r>
-              <a:rPr lang="en-US" sz="1900" b="1" dirty="0">
-                <a:solidFill>
-                  <a:srgbClr val="0A1F3B"/>
-                </a:solidFill>
-                <a:latin typeface="Cambria" pitchFamily="34" charset="0"/>
-                <a:ea typeface="Cambria" pitchFamily="34" charset="-122"/>
-                <a:cs typeface="Cambria" pitchFamily="34" charset="-120"/>
-              </a:rPr>
-              <a:t>TODOS</a:t>
-            </a:r>
-            <a:endParaRPr lang="en-US" sz="1900" dirty="0"/>
-          </a:p>
-        </p:txBody>
-      </p:sp>
-      <p:sp>
-        <p:nvSpPr>
-          <p:cNvPr id="27" name="Text 19"/>
+          <p:cNvPr id="22" name="Text 14"/>
           <p:cNvSpPr txBox="1"/>
           <p:nvPr/>
         </p:nvSpPr>
@@ -21412,7 +21292,7 @@
       </p:sp>
       <p:sp>
         <p:nvSpPr>
-          <p:cNvPr id="28" name="Text 20"/>
+          <p:cNvPr id="23" name="Text 15"/>
           <p:cNvSpPr txBox="1"/>
           <p:nvPr/>
         </p:nvSpPr>
@@ -21451,7 +21331,7 @@
       </p:sp>
       <p:sp>
         <p:nvSpPr>
-          <p:cNvPr id="29" name="Text 21"/>
+          <p:cNvPr id="24" name="Text 16"/>
           <p:cNvSpPr txBox="1"/>
           <p:nvPr/>
         </p:nvSpPr>
@@ -24042,7 +23922,7 @@
             <a:r>
               <a:rPr lang="en-US" sz="1200" b="1" spc="200" kern="0" dirty="0">
                 <a:solidFill>
-                  <a:srgbClr val="17A9B0"/>
+                  <a:srgbClr val="97D8DB"/>
                 </a:solidFill>
                 <a:latin typeface="Calibri" pitchFamily="34" charset="0"/>
                 <a:ea typeface="Calibri" pitchFamily="34" charset="-122"/>
@@ -25605,7 +25485,7 @@
             <a:r>
               <a:rPr lang="en-US" sz="1200" b="1" spc="200" kern="0" dirty="0">
                 <a:solidFill>
-                  <a:srgbClr val="3A6EA5"/>
+                  <a:srgbClr val="A6BED7"/>
                 </a:solidFill>
                 <a:latin typeface="Calibri" pitchFamily="34" charset="0"/>
                 <a:ea typeface="Calibri" pitchFamily="34" charset="-122"/>
@@ -27107,7 +26987,7 @@
             <a:r>
               <a:rPr lang="en-US" sz="1200" b="1" spc="200" kern="0" dirty="0">
                 <a:solidFill>
-                  <a:srgbClr val="1B4F91"/>
+                  <a:srgbClr val="98B0CE"/>
                 </a:solidFill>
                 <a:latin typeface="Calibri" pitchFamily="34" charset="0"/>
                 <a:ea typeface="Calibri" pitchFamily="34" charset="-122"/>
@@ -30132,7 +30012,7 @@
             <a:r>
               <a:rPr lang="en-US" sz="1200" b="1" spc="200" kern="0" dirty="0">
                 <a:solidFill>
-                  <a:srgbClr val="2E5EAA"/>
+                  <a:srgbClr val="A1B7D9"/>
                 </a:solidFill>
                 <a:latin typeface="Calibri" pitchFamily="34" charset="0"/>
                 <a:ea typeface="Calibri" pitchFamily="34" charset="-122"/>

</xml_diff>

<commit_message>
Fix click-to-reveal animations not triggering in PowerPoint
The injected <p:timing> tree was missing the click-advance wiring on the
<p:seq> element itself (prevCondLst/nextCondLst tying mouse clicks to
advancing through the animation sequence) — without it, PowerPoint has no
way to know a click should progress the pending "wait for click" animation,
so nothing happened when clicking during the slide show. Added the missing
sequence-level condition list and deepened the timing tree to match
PowerPoint's standard on-click "Appear" structure.

Co-Authored-By: Claude Sonnet 5 <noreply@anthropic.com>
Claude-Session: https://claude.ai/code/session_01VbDBTsyG5QwHCNDLUQQk1r
</commit_message>
<xml_diff>
--- a/capacitacion-riesgos-2025/CAPACITACION_RIESGOS_2025.pptx
+++ b/capacitacion-riesgos-2025/CAPACITACION_RIESGOS_2025.pptx
@@ -8067,137 +8067,146 @@
                       </p:stCondLst>
                       <p:childTnLst>
                         <p:par>
-                          <p:cTn id="4" presetID="2" presetClass="entr" presetSubtype="0" fill="hold" nodeType="clickEffect">
+                          <p:cTn id="4" fill="hold">
                             <p:stCondLst>
                               <p:cond delay="0"/>
                             </p:stCondLst>
                             <p:childTnLst>
-                              <p:set>
-                                <p:cBhvr>
-                                  <p:cTn id="5" dur="1" fill="hold">
-                                    <p:stCondLst>
-                                      <p:cond delay="0"/>
-                                    </p:stCondLst>
-                                  </p:cTn>
-                                  <p:tgtEl>
-                                    <p:spTgt spid="23"/>
-                                  </p:tgtEl>
-                                  <p:attrNameLst>
-                                    <p:attrName>style.visibility</p:attrName>
-                                  </p:attrNameLst>
-                                </p:cBhvr>
-                                <p:to>
-                                  <p:strVal val="visible"/>
-                                </p:to>
-                              </p:set>
-                              <p:set>
-                                <p:cBhvr>
-                                  <p:cTn id="6" dur="1" fill="hold">
-                                    <p:stCondLst>
-                                      <p:cond delay="0"/>
-                                    </p:stCondLst>
-                                  </p:cTn>
-                                  <p:tgtEl>
-                                    <p:spTgt spid="24"/>
-                                  </p:tgtEl>
-                                  <p:attrNameLst>
-                                    <p:attrName>style.visibility</p:attrName>
-                                  </p:attrNameLst>
-                                </p:cBhvr>
-                                <p:to>
-                                  <p:strVal val="visible"/>
-                                </p:to>
-                              </p:set>
-                              <p:set>
-                                <p:cBhvr>
-                                  <p:cTn id="7" dur="1" fill="hold">
-                                    <p:stCondLst>
-                                      <p:cond delay="0"/>
-                                    </p:stCondLst>
-                                  </p:cTn>
-                                  <p:tgtEl>
-                                    <p:spTgt spid="25"/>
-                                  </p:tgtEl>
-                                  <p:attrNameLst>
-                                    <p:attrName>style.visibility</p:attrName>
-                                  </p:attrNameLst>
-                                </p:cBhvr>
-                                <p:to>
-                                  <p:strVal val="visible"/>
-                                </p:to>
-                              </p:set>
-                              <p:set>
-                                <p:cBhvr>
-                                  <p:cTn id="8" dur="1" fill="hold">
-                                    <p:stCondLst>
-                                      <p:cond delay="0"/>
-                                    </p:stCondLst>
-                                  </p:cTn>
-                                  <p:tgtEl>
-                                    <p:spTgt spid="26"/>
-                                  </p:tgtEl>
-                                  <p:attrNameLst>
-                                    <p:attrName>style.visibility</p:attrName>
-                                  </p:attrNameLst>
-                                </p:cBhvr>
-                                <p:to>
-                                  <p:strVal val="visible"/>
-                                </p:to>
-                              </p:set>
-                              <p:set>
-                                <p:cBhvr>
-                                  <p:cTn id="9" dur="1" fill="hold">
-                                    <p:stCondLst>
-                                      <p:cond delay="0"/>
-                                    </p:stCondLst>
-                                  </p:cTn>
-                                  <p:tgtEl>
-                                    <p:spTgt spid="27"/>
-                                  </p:tgtEl>
-                                  <p:attrNameLst>
-                                    <p:attrName>style.visibility</p:attrName>
-                                  </p:attrNameLst>
-                                </p:cBhvr>
-                                <p:to>
-                                  <p:strVal val="visible"/>
-                                </p:to>
-                              </p:set>
-                              <p:set>
-                                <p:cBhvr>
-                                  <p:cTn id="10" dur="1" fill="hold">
-                                    <p:stCondLst>
-                                      <p:cond delay="0"/>
-                                    </p:stCondLst>
-                                  </p:cTn>
-                                  <p:tgtEl>
-                                    <p:spTgt spid="28"/>
-                                  </p:tgtEl>
-                                  <p:attrNameLst>
-                                    <p:attrName>style.visibility</p:attrName>
-                                  </p:attrNameLst>
-                                </p:cBhvr>
-                                <p:to>
-                                  <p:strVal val="visible"/>
-                                </p:to>
-                              </p:set>
-                              <p:set>
-                                <p:cBhvr>
-                                  <p:cTn id="11" dur="1" fill="hold">
-                                    <p:stCondLst>
-                                      <p:cond delay="0"/>
-                                    </p:stCondLst>
-                                  </p:cTn>
-                                  <p:tgtEl>
-                                    <p:spTgt spid="29"/>
-                                  </p:tgtEl>
-                                  <p:attrNameLst>
-                                    <p:attrName>style.visibility</p:attrName>
-                                  </p:attrNameLst>
-                                </p:cBhvr>
-                                <p:to>
-                                  <p:strVal val="visible"/>
-                                </p:to>
-                              </p:set>
+                              <p:par>
+                                <p:cTn id="5" presetID="2" presetClass="entr" presetSubtype="0" fill="hold" grpId="0" nodeType="clickEffect">
+                                  <p:stCondLst>
+                                    <p:cond delay="0"/>
+                                  </p:stCondLst>
+                                  <p:childTnLst>
+                                    <p:set>
+                                      <p:cBhvr>
+                                        <p:cTn id="6" dur="1" fill="hold">
+                                          <p:stCondLst>
+                                            <p:cond delay="0"/>
+                                          </p:stCondLst>
+                                        </p:cTn>
+                                        <p:tgtEl>
+                                          <p:spTgt spid="23"/>
+                                        </p:tgtEl>
+                                        <p:attrNameLst>
+                                          <p:attrName>style.visibility</p:attrName>
+                                        </p:attrNameLst>
+                                      </p:cBhvr>
+                                      <p:to>
+                                        <p:strVal val="visible"/>
+                                      </p:to>
+                                    </p:set>
+                                    <p:set>
+                                      <p:cBhvr>
+                                        <p:cTn id="7" dur="1" fill="hold">
+                                          <p:stCondLst>
+                                            <p:cond delay="0"/>
+                                          </p:stCondLst>
+                                        </p:cTn>
+                                        <p:tgtEl>
+                                          <p:spTgt spid="24"/>
+                                        </p:tgtEl>
+                                        <p:attrNameLst>
+                                          <p:attrName>style.visibility</p:attrName>
+                                        </p:attrNameLst>
+                                      </p:cBhvr>
+                                      <p:to>
+                                        <p:strVal val="visible"/>
+                                      </p:to>
+                                    </p:set>
+                                    <p:set>
+                                      <p:cBhvr>
+                                        <p:cTn id="8" dur="1" fill="hold">
+                                          <p:stCondLst>
+                                            <p:cond delay="0"/>
+                                          </p:stCondLst>
+                                        </p:cTn>
+                                        <p:tgtEl>
+                                          <p:spTgt spid="25"/>
+                                        </p:tgtEl>
+                                        <p:attrNameLst>
+                                          <p:attrName>style.visibility</p:attrName>
+                                        </p:attrNameLst>
+                                      </p:cBhvr>
+                                      <p:to>
+                                        <p:strVal val="visible"/>
+                                      </p:to>
+                                    </p:set>
+                                    <p:set>
+                                      <p:cBhvr>
+                                        <p:cTn id="9" dur="1" fill="hold">
+                                          <p:stCondLst>
+                                            <p:cond delay="0"/>
+                                          </p:stCondLst>
+                                        </p:cTn>
+                                        <p:tgtEl>
+                                          <p:spTgt spid="26"/>
+                                        </p:tgtEl>
+                                        <p:attrNameLst>
+                                          <p:attrName>style.visibility</p:attrName>
+                                        </p:attrNameLst>
+                                      </p:cBhvr>
+                                      <p:to>
+                                        <p:strVal val="visible"/>
+                                      </p:to>
+                                    </p:set>
+                                    <p:set>
+                                      <p:cBhvr>
+                                        <p:cTn id="10" dur="1" fill="hold">
+                                          <p:stCondLst>
+                                            <p:cond delay="0"/>
+                                          </p:stCondLst>
+                                        </p:cTn>
+                                        <p:tgtEl>
+                                          <p:spTgt spid="27"/>
+                                        </p:tgtEl>
+                                        <p:attrNameLst>
+                                          <p:attrName>style.visibility</p:attrName>
+                                        </p:attrNameLst>
+                                      </p:cBhvr>
+                                      <p:to>
+                                        <p:strVal val="visible"/>
+                                      </p:to>
+                                    </p:set>
+                                    <p:set>
+                                      <p:cBhvr>
+                                        <p:cTn id="11" dur="1" fill="hold">
+                                          <p:stCondLst>
+                                            <p:cond delay="0"/>
+                                          </p:stCondLst>
+                                        </p:cTn>
+                                        <p:tgtEl>
+                                          <p:spTgt spid="28"/>
+                                        </p:tgtEl>
+                                        <p:attrNameLst>
+                                          <p:attrName>style.visibility</p:attrName>
+                                        </p:attrNameLst>
+                                      </p:cBhvr>
+                                      <p:to>
+                                        <p:strVal val="visible"/>
+                                      </p:to>
+                                    </p:set>
+                                    <p:set>
+                                      <p:cBhvr>
+                                        <p:cTn id="12" dur="1" fill="hold">
+                                          <p:stCondLst>
+                                            <p:cond delay="0"/>
+                                          </p:stCondLst>
+                                        </p:cTn>
+                                        <p:tgtEl>
+                                          <p:spTgt spid="29"/>
+                                        </p:tgtEl>
+                                        <p:attrNameLst>
+                                          <p:attrName>style.visibility</p:attrName>
+                                        </p:attrNameLst>
+                                      </p:cBhvr>
+                                      <p:to>
+                                        <p:strVal val="visible"/>
+                                      </p:to>
+                                    </p:set>
+                                  </p:childTnLst>
+                                </p:cTn>
+                              </p:par>
                             </p:childTnLst>
                           </p:cTn>
                         </p:par>
@@ -8206,6 +8215,20 @@
                   </p:par>
                 </p:childTnLst>
               </p:cTn>
+              <p:prevCondLst>
+                <p:cond evt="onPrev" delay="0">
+                  <p:tgtEl>
+                    <p:sldTgt/>
+                  </p:tgtEl>
+                </p:cond>
+              </p:prevCondLst>
+              <p:nextCondLst>
+                <p:cond evt="onNext" delay="0">
+                  <p:tgtEl>
+                    <p:sldTgt/>
+                  </p:tgtEl>
+                </p:cond>
+              </p:nextCondLst>
             </p:seq>
           </p:childTnLst>
         </p:cTn>
@@ -10905,155 +10928,164 @@
                       </p:stCondLst>
                       <p:childTnLst>
                         <p:par>
-                          <p:cTn id="4" presetID="2" presetClass="entr" presetSubtype="0" fill="hold" nodeType="clickEffect">
+                          <p:cTn id="4" fill="hold">
                             <p:stCondLst>
                               <p:cond delay="0"/>
                             </p:stCondLst>
                             <p:childTnLst>
-                              <p:set>
-                                <p:cBhvr>
-                                  <p:cTn id="5" dur="1" fill="hold">
-                                    <p:stCondLst>
-                                      <p:cond delay="0"/>
-                                    </p:stCondLst>
-                                  </p:cTn>
-                                  <p:tgtEl>
-                                    <p:spTgt spid="14"/>
-                                  </p:tgtEl>
-                                  <p:attrNameLst>
-                                    <p:attrName>style.visibility</p:attrName>
-                                  </p:attrNameLst>
-                                </p:cBhvr>
-                                <p:to>
-                                  <p:strVal val="visible"/>
-                                </p:to>
-                              </p:set>
-                              <p:set>
-                                <p:cBhvr>
-                                  <p:cTn id="6" dur="1" fill="hold">
-                                    <p:stCondLst>
-                                      <p:cond delay="0"/>
-                                    </p:stCondLst>
-                                  </p:cTn>
-                                  <p:tgtEl>
-                                    <p:spTgt spid="15"/>
-                                  </p:tgtEl>
-                                  <p:attrNameLst>
-                                    <p:attrName>style.visibility</p:attrName>
-                                  </p:attrNameLst>
-                                </p:cBhvr>
-                                <p:to>
-                                  <p:strVal val="visible"/>
-                                </p:to>
-                              </p:set>
-                              <p:set>
-                                <p:cBhvr>
-                                  <p:cTn id="7" dur="1" fill="hold">
-                                    <p:stCondLst>
-                                      <p:cond delay="0"/>
-                                    </p:stCondLst>
-                                  </p:cTn>
-                                  <p:tgtEl>
-                                    <p:spTgt spid="24"/>
-                                  </p:tgtEl>
-                                  <p:attrNameLst>
-                                    <p:attrName>style.visibility</p:attrName>
-                                  </p:attrNameLst>
-                                </p:cBhvr>
-                                <p:to>
-                                  <p:strVal val="visible"/>
-                                </p:to>
-                              </p:set>
-                              <p:set>
-                                <p:cBhvr>
-                                  <p:cTn id="8" dur="1" fill="hold">
-                                    <p:stCondLst>
-                                      <p:cond delay="0"/>
-                                    </p:stCondLst>
-                                  </p:cTn>
-                                  <p:tgtEl>
-                                    <p:spTgt spid="25"/>
-                                  </p:tgtEl>
-                                  <p:attrNameLst>
-                                    <p:attrName>style.visibility</p:attrName>
-                                  </p:attrNameLst>
-                                </p:cBhvr>
-                                <p:to>
-                                  <p:strVal val="visible"/>
-                                </p:to>
-                              </p:set>
-                              <p:set>
-                                <p:cBhvr>
-                                  <p:cTn id="9" dur="1" fill="hold">
-                                    <p:stCondLst>
-                                      <p:cond delay="0"/>
-                                    </p:stCondLst>
-                                  </p:cTn>
-                                  <p:tgtEl>
-                                    <p:spTgt spid="34"/>
-                                  </p:tgtEl>
-                                  <p:attrNameLst>
-                                    <p:attrName>style.visibility</p:attrName>
-                                  </p:attrNameLst>
-                                </p:cBhvr>
-                                <p:to>
-                                  <p:strVal val="visible"/>
-                                </p:to>
-                              </p:set>
-                              <p:set>
-                                <p:cBhvr>
-                                  <p:cTn id="10" dur="1" fill="hold">
-                                    <p:stCondLst>
-                                      <p:cond delay="0"/>
-                                    </p:stCondLst>
-                                  </p:cTn>
-                                  <p:tgtEl>
-                                    <p:spTgt spid="35"/>
-                                  </p:tgtEl>
-                                  <p:attrNameLst>
-                                    <p:attrName>style.visibility</p:attrName>
-                                  </p:attrNameLst>
-                                </p:cBhvr>
-                                <p:to>
-                                  <p:strVal val="visible"/>
-                                </p:to>
-                              </p:set>
-                              <p:set>
-                                <p:cBhvr>
-                                  <p:cTn id="11" dur="1" fill="hold">
-                                    <p:stCondLst>
-                                      <p:cond delay="0"/>
-                                    </p:stCondLst>
-                                  </p:cTn>
-                                  <p:tgtEl>
-                                    <p:spTgt spid="44"/>
-                                  </p:tgtEl>
-                                  <p:attrNameLst>
-                                    <p:attrName>style.visibility</p:attrName>
-                                  </p:attrNameLst>
-                                </p:cBhvr>
-                                <p:to>
-                                  <p:strVal val="visible"/>
-                                </p:to>
-                              </p:set>
-                              <p:set>
-                                <p:cBhvr>
-                                  <p:cTn id="12" dur="1" fill="hold">
-                                    <p:stCondLst>
-                                      <p:cond delay="0"/>
-                                    </p:stCondLst>
-                                  </p:cTn>
-                                  <p:tgtEl>
-                                    <p:spTgt spid="45"/>
-                                  </p:tgtEl>
-                                  <p:attrNameLst>
-                                    <p:attrName>style.visibility</p:attrName>
-                                  </p:attrNameLst>
-                                </p:cBhvr>
-                                <p:to>
-                                  <p:strVal val="visible"/>
-                                </p:to>
-                              </p:set>
+                              <p:par>
+                                <p:cTn id="5" presetID="2" presetClass="entr" presetSubtype="0" fill="hold" grpId="0" nodeType="clickEffect">
+                                  <p:stCondLst>
+                                    <p:cond delay="0"/>
+                                  </p:stCondLst>
+                                  <p:childTnLst>
+                                    <p:set>
+                                      <p:cBhvr>
+                                        <p:cTn id="6" dur="1" fill="hold">
+                                          <p:stCondLst>
+                                            <p:cond delay="0"/>
+                                          </p:stCondLst>
+                                        </p:cTn>
+                                        <p:tgtEl>
+                                          <p:spTgt spid="14"/>
+                                        </p:tgtEl>
+                                        <p:attrNameLst>
+                                          <p:attrName>style.visibility</p:attrName>
+                                        </p:attrNameLst>
+                                      </p:cBhvr>
+                                      <p:to>
+                                        <p:strVal val="visible"/>
+                                      </p:to>
+                                    </p:set>
+                                    <p:set>
+                                      <p:cBhvr>
+                                        <p:cTn id="7" dur="1" fill="hold">
+                                          <p:stCondLst>
+                                            <p:cond delay="0"/>
+                                          </p:stCondLst>
+                                        </p:cTn>
+                                        <p:tgtEl>
+                                          <p:spTgt spid="15"/>
+                                        </p:tgtEl>
+                                        <p:attrNameLst>
+                                          <p:attrName>style.visibility</p:attrName>
+                                        </p:attrNameLst>
+                                      </p:cBhvr>
+                                      <p:to>
+                                        <p:strVal val="visible"/>
+                                      </p:to>
+                                    </p:set>
+                                    <p:set>
+                                      <p:cBhvr>
+                                        <p:cTn id="8" dur="1" fill="hold">
+                                          <p:stCondLst>
+                                            <p:cond delay="0"/>
+                                          </p:stCondLst>
+                                        </p:cTn>
+                                        <p:tgtEl>
+                                          <p:spTgt spid="24"/>
+                                        </p:tgtEl>
+                                        <p:attrNameLst>
+                                          <p:attrName>style.visibility</p:attrName>
+                                        </p:attrNameLst>
+                                      </p:cBhvr>
+                                      <p:to>
+                                        <p:strVal val="visible"/>
+                                      </p:to>
+                                    </p:set>
+                                    <p:set>
+                                      <p:cBhvr>
+                                        <p:cTn id="9" dur="1" fill="hold">
+                                          <p:stCondLst>
+                                            <p:cond delay="0"/>
+                                          </p:stCondLst>
+                                        </p:cTn>
+                                        <p:tgtEl>
+                                          <p:spTgt spid="25"/>
+                                        </p:tgtEl>
+                                        <p:attrNameLst>
+                                          <p:attrName>style.visibility</p:attrName>
+                                        </p:attrNameLst>
+                                      </p:cBhvr>
+                                      <p:to>
+                                        <p:strVal val="visible"/>
+                                      </p:to>
+                                    </p:set>
+                                    <p:set>
+                                      <p:cBhvr>
+                                        <p:cTn id="10" dur="1" fill="hold">
+                                          <p:stCondLst>
+                                            <p:cond delay="0"/>
+                                          </p:stCondLst>
+                                        </p:cTn>
+                                        <p:tgtEl>
+                                          <p:spTgt spid="34"/>
+                                        </p:tgtEl>
+                                        <p:attrNameLst>
+                                          <p:attrName>style.visibility</p:attrName>
+                                        </p:attrNameLst>
+                                      </p:cBhvr>
+                                      <p:to>
+                                        <p:strVal val="visible"/>
+                                      </p:to>
+                                    </p:set>
+                                    <p:set>
+                                      <p:cBhvr>
+                                        <p:cTn id="11" dur="1" fill="hold">
+                                          <p:stCondLst>
+                                            <p:cond delay="0"/>
+                                          </p:stCondLst>
+                                        </p:cTn>
+                                        <p:tgtEl>
+                                          <p:spTgt spid="35"/>
+                                        </p:tgtEl>
+                                        <p:attrNameLst>
+                                          <p:attrName>style.visibility</p:attrName>
+                                        </p:attrNameLst>
+                                      </p:cBhvr>
+                                      <p:to>
+                                        <p:strVal val="visible"/>
+                                      </p:to>
+                                    </p:set>
+                                    <p:set>
+                                      <p:cBhvr>
+                                        <p:cTn id="12" dur="1" fill="hold">
+                                          <p:stCondLst>
+                                            <p:cond delay="0"/>
+                                          </p:stCondLst>
+                                        </p:cTn>
+                                        <p:tgtEl>
+                                          <p:spTgt spid="44"/>
+                                        </p:tgtEl>
+                                        <p:attrNameLst>
+                                          <p:attrName>style.visibility</p:attrName>
+                                        </p:attrNameLst>
+                                      </p:cBhvr>
+                                      <p:to>
+                                        <p:strVal val="visible"/>
+                                      </p:to>
+                                    </p:set>
+                                    <p:set>
+                                      <p:cBhvr>
+                                        <p:cTn id="13" dur="1" fill="hold">
+                                          <p:stCondLst>
+                                            <p:cond delay="0"/>
+                                          </p:stCondLst>
+                                        </p:cTn>
+                                        <p:tgtEl>
+                                          <p:spTgt spid="45"/>
+                                        </p:tgtEl>
+                                        <p:attrNameLst>
+                                          <p:attrName>style.visibility</p:attrName>
+                                        </p:attrNameLst>
+                                      </p:cBhvr>
+                                      <p:to>
+                                        <p:strVal val="visible"/>
+                                      </p:to>
+                                    </p:set>
+                                  </p:childTnLst>
+                                </p:cTn>
+                              </p:par>
                             </p:childTnLst>
                           </p:cTn>
                         </p:par>
@@ -11062,6 +11094,20 @@
                   </p:par>
                 </p:childTnLst>
               </p:cTn>
+              <p:prevCondLst>
+                <p:cond evt="onPrev" delay="0">
+                  <p:tgtEl>
+                    <p:sldTgt/>
+                  </p:tgtEl>
+                </p:cond>
+              </p:prevCondLst>
+              <p:nextCondLst>
+                <p:cond evt="onNext" delay="0">
+                  <p:tgtEl>
+                    <p:sldTgt/>
+                  </p:tgtEl>
+                </p:cond>
+              </p:nextCondLst>
             </p:seq>
           </p:childTnLst>
         </p:cTn>
@@ -19600,281 +19646,290 @@
                       </p:stCondLst>
                       <p:childTnLst>
                         <p:par>
-                          <p:cTn id="4" presetID="2" presetClass="entr" presetSubtype="0" fill="hold" nodeType="clickEffect">
+                          <p:cTn id="4" fill="hold">
                             <p:stCondLst>
                               <p:cond delay="0"/>
                             </p:stCondLst>
                             <p:childTnLst>
-                              <p:set>
-                                <p:cBhvr>
-                                  <p:cTn id="5" dur="1" fill="hold">
-                                    <p:stCondLst>
-                                      <p:cond delay="0"/>
-                                    </p:stCondLst>
-                                  </p:cTn>
-                                  <p:tgtEl>
-                                    <p:spTgt spid="22"/>
-                                  </p:tgtEl>
-                                  <p:attrNameLst>
-                                    <p:attrName>style.visibility</p:attrName>
-                                  </p:attrNameLst>
-                                </p:cBhvr>
-                                <p:to>
-                                  <p:strVal val="visible"/>
-                                </p:to>
-                              </p:set>
-                              <p:set>
-                                <p:cBhvr>
-                                  <p:cTn id="6" dur="1" fill="hold">
-                                    <p:stCondLst>
-                                      <p:cond delay="0"/>
-                                    </p:stCondLst>
-                                  </p:cTn>
-                                  <p:tgtEl>
-                                    <p:spTgt spid="23"/>
-                                  </p:tgtEl>
-                                  <p:attrNameLst>
-                                    <p:attrName>style.visibility</p:attrName>
-                                  </p:attrNameLst>
-                                </p:cBhvr>
-                                <p:to>
-                                  <p:strVal val="visible"/>
-                                </p:to>
-                              </p:set>
-                              <p:set>
-                                <p:cBhvr>
-                                  <p:cTn id="7" dur="1" fill="hold">
-                                    <p:stCondLst>
-                                      <p:cond delay="0"/>
-                                    </p:stCondLst>
-                                  </p:cTn>
-                                  <p:tgtEl>
-                                    <p:spTgt spid="24"/>
-                                  </p:tgtEl>
-                                  <p:attrNameLst>
-                                    <p:attrName>style.visibility</p:attrName>
-                                  </p:attrNameLst>
-                                </p:cBhvr>
-                                <p:to>
-                                  <p:strVal val="visible"/>
-                                </p:to>
-                              </p:set>
-                              <p:set>
-                                <p:cBhvr>
-                                  <p:cTn id="8" dur="1" fill="hold">
-                                    <p:stCondLst>
-                                      <p:cond delay="0"/>
-                                    </p:stCondLst>
-                                  </p:cTn>
-                                  <p:tgtEl>
-                                    <p:spTgt spid="25"/>
-                                  </p:tgtEl>
-                                  <p:attrNameLst>
-                                    <p:attrName>style.visibility</p:attrName>
-                                  </p:attrNameLst>
-                                </p:cBhvr>
-                                <p:to>
-                                  <p:strVal val="visible"/>
-                                </p:to>
-                              </p:set>
-                              <p:set>
-                                <p:cBhvr>
-                                  <p:cTn id="9" dur="1" fill="hold">
-                                    <p:stCondLst>
-                                      <p:cond delay="0"/>
-                                    </p:stCondLst>
-                                  </p:cTn>
-                                  <p:tgtEl>
-                                    <p:spTgt spid="26"/>
-                                  </p:tgtEl>
-                                  <p:attrNameLst>
-                                    <p:attrName>style.visibility</p:attrName>
-                                  </p:attrNameLst>
-                                </p:cBhvr>
-                                <p:to>
-                                  <p:strVal val="visible"/>
-                                </p:to>
-                              </p:set>
-                              <p:set>
-                                <p:cBhvr>
-                                  <p:cTn id="10" dur="1" fill="hold">
-                                    <p:stCondLst>
-                                      <p:cond delay="0"/>
-                                    </p:stCondLst>
-                                  </p:cTn>
-                                  <p:tgtEl>
-                                    <p:spTgt spid="27"/>
-                                  </p:tgtEl>
-                                  <p:attrNameLst>
-                                    <p:attrName>style.visibility</p:attrName>
-                                  </p:attrNameLst>
-                                </p:cBhvr>
-                                <p:to>
-                                  <p:strVal val="visible"/>
-                                </p:to>
-                              </p:set>
-                              <p:set>
-                                <p:cBhvr>
-                                  <p:cTn id="11" dur="1" fill="hold">
-                                    <p:stCondLst>
-                                      <p:cond delay="0"/>
-                                    </p:stCondLst>
-                                  </p:cTn>
-                                  <p:tgtEl>
-                                    <p:spTgt spid="28"/>
-                                  </p:tgtEl>
-                                  <p:attrNameLst>
-                                    <p:attrName>style.visibility</p:attrName>
-                                  </p:attrNameLst>
-                                </p:cBhvr>
-                                <p:to>
-                                  <p:strVal val="visible"/>
-                                </p:to>
-                              </p:set>
-                              <p:set>
-                                <p:cBhvr>
-                                  <p:cTn id="12" dur="1" fill="hold">
-                                    <p:stCondLst>
-                                      <p:cond delay="0"/>
-                                    </p:stCondLst>
-                                  </p:cTn>
-                                  <p:tgtEl>
-                                    <p:spTgt spid="29"/>
-                                  </p:tgtEl>
-                                  <p:attrNameLst>
-                                    <p:attrName>style.visibility</p:attrName>
-                                  </p:attrNameLst>
-                                </p:cBhvr>
-                                <p:to>
-                                  <p:strVal val="visible"/>
-                                </p:to>
-                              </p:set>
-                              <p:set>
-                                <p:cBhvr>
-                                  <p:cTn id="13" dur="1" fill="hold">
-                                    <p:stCondLst>
-                                      <p:cond delay="0"/>
-                                    </p:stCondLst>
-                                  </p:cTn>
-                                  <p:tgtEl>
-                                    <p:spTgt spid="30"/>
-                                  </p:tgtEl>
-                                  <p:attrNameLst>
-                                    <p:attrName>style.visibility</p:attrName>
-                                  </p:attrNameLst>
-                                </p:cBhvr>
-                                <p:to>
-                                  <p:strVal val="visible"/>
-                                </p:to>
-                              </p:set>
-                              <p:set>
-                                <p:cBhvr>
-                                  <p:cTn id="14" dur="1" fill="hold">
-                                    <p:stCondLst>
-                                      <p:cond delay="0"/>
-                                    </p:stCondLst>
-                                  </p:cTn>
-                                  <p:tgtEl>
-                                    <p:spTgt spid="31"/>
-                                  </p:tgtEl>
-                                  <p:attrNameLst>
-                                    <p:attrName>style.visibility</p:attrName>
-                                  </p:attrNameLst>
-                                </p:cBhvr>
-                                <p:to>
-                                  <p:strVal val="visible"/>
-                                </p:to>
-                              </p:set>
-                              <p:set>
-                                <p:cBhvr>
-                                  <p:cTn id="15" dur="1" fill="hold">
-                                    <p:stCondLst>
-                                      <p:cond delay="0"/>
-                                    </p:stCondLst>
-                                  </p:cTn>
-                                  <p:tgtEl>
-                                    <p:spTgt spid="32"/>
-                                  </p:tgtEl>
-                                  <p:attrNameLst>
-                                    <p:attrName>style.visibility</p:attrName>
-                                  </p:attrNameLst>
-                                </p:cBhvr>
-                                <p:to>
-                                  <p:strVal val="visible"/>
-                                </p:to>
-                              </p:set>
-                              <p:set>
-                                <p:cBhvr>
-                                  <p:cTn id="16" dur="1" fill="hold">
-                                    <p:stCondLst>
-                                      <p:cond delay="0"/>
-                                    </p:stCondLst>
-                                  </p:cTn>
-                                  <p:tgtEl>
-                                    <p:spTgt spid="33"/>
-                                  </p:tgtEl>
-                                  <p:attrNameLst>
-                                    <p:attrName>style.visibility</p:attrName>
-                                  </p:attrNameLst>
-                                </p:cBhvr>
-                                <p:to>
-                                  <p:strVal val="visible"/>
-                                </p:to>
-                              </p:set>
-                              <p:set>
-                                <p:cBhvr>
-                                  <p:cTn id="17" dur="1" fill="hold">
-                                    <p:stCondLst>
-                                      <p:cond delay="0"/>
-                                    </p:stCondLst>
-                                  </p:cTn>
-                                  <p:tgtEl>
-                                    <p:spTgt spid="34"/>
-                                  </p:tgtEl>
-                                  <p:attrNameLst>
-                                    <p:attrName>style.visibility</p:attrName>
-                                  </p:attrNameLst>
-                                </p:cBhvr>
-                                <p:to>
-                                  <p:strVal val="visible"/>
-                                </p:to>
-                              </p:set>
-                              <p:set>
-                                <p:cBhvr>
-                                  <p:cTn id="18" dur="1" fill="hold">
-                                    <p:stCondLst>
-                                      <p:cond delay="0"/>
-                                    </p:stCondLst>
-                                  </p:cTn>
-                                  <p:tgtEl>
-                                    <p:spTgt spid="35"/>
-                                  </p:tgtEl>
-                                  <p:attrNameLst>
-                                    <p:attrName>style.visibility</p:attrName>
-                                  </p:attrNameLst>
-                                </p:cBhvr>
-                                <p:to>
-                                  <p:strVal val="visible"/>
-                                </p:to>
-                              </p:set>
-                              <p:set>
-                                <p:cBhvr>
-                                  <p:cTn id="19" dur="1" fill="hold">
-                                    <p:stCondLst>
-                                      <p:cond delay="0"/>
-                                    </p:stCondLst>
-                                  </p:cTn>
-                                  <p:tgtEl>
-                                    <p:spTgt spid="36"/>
-                                  </p:tgtEl>
-                                  <p:attrNameLst>
-                                    <p:attrName>style.visibility</p:attrName>
-                                  </p:attrNameLst>
-                                </p:cBhvr>
-                                <p:to>
-                                  <p:strVal val="visible"/>
-                                </p:to>
-                              </p:set>
+                              <p:par>
+                                <p:cTn id="5" presetID="2" presetClass="entr" presetSubtype="0" fill="hold" grpId="0" nodeType="clickEffect">
+                                  <p:stCondLst>
+                                    <p:cond delay="0"/>
+                                  </p:stCondLst>
+                                  <p:childTnLst>
+                                    <p:set>
+                                      <p:cBhvr>
+                                        <p:cTn id="6" dur="1" fill="hold">
+                                          <p:stCondLst>
+                                            <p:cond delay="0"/>
+                                          </p:stCondLst>
+                                        </p:cTn>
+                                        <p:tgtEl>
+                                          <p:spTgt spid="22"/>
+                                        </p:tgtEl>
+                                        <p:attrNameLst>
+                                          <p:attrName>style.visibility</p:attrName>
+                                        </p:attrNameLst>
+                                      </p:cBhvr>
+                                      <p:to>
+                                        <p:strVal val="visible"/>
+                                      </p:to>
+                                    </p:set>
+                                    <p:set>
+                                      <p:cBhvr>
+                                        <p:cTn id="7" dur="1" fill="hold">
+                                          <p:stCondLst>
+                                            <p:cond delay="0"/>
+                                          </p:stCondLst>
+                                        </p:cTn>
+                                        <p:tgtEl>
+                                          <p:spTgt spid="23"/>
+                                        </p:tgtEl>
+                                        <p:attrNameLst>
+                                          <p:attrName>style.visibility</p:attrName>
+                                        </p:attrNameLst>
+                                      </p:cBhvr>
+                                      <p:to>
+                                        <p:strVal val="visible"/>
+                                      </p:to>
+                                    </p:set>
+                                    <p:set>
+                                      <p:cBhvr>
+                                        <p:cTn id="8" dur="1" fill="hold">
+                                          <p:stCondLst>
+                                            <p:cond delay="0"/>
+                                          </p:stCondLst>
+                                        </p:cTn>
+                                        <p:tgtEl>
+                                          <p:spTgt spid="24"/>
+                                        </p:tgtEl>
+                                        <p:attrNameLst>
+                                          <p:attrName>style.visibility</p:attrName>
+                                        </p:attrNameLst>
+                                      </p:cBhvr>
+                                      <p:to>
+                                        <p:strVal val="visible"/>
+                                      </p:to>
+                                    </p:set>
+                                    <p:set>
+                                      <p:cBhvr>
+                                        <p:cTn id="9" dur="1" fill="hold">
+                                          <p:stCondLst>
+                                            <p:cond delay="0"/>
+                                          </p:stCondLst>
+                                        </p:cTn>
+                                        <p:tgtEl>
+                                          <p:spTgt spid="25"/>
+                                        </p:tgtEl>
+                                        <p:attrNameLst>
+                                          <p:attrName>style.visibility</p:attrName>
+                                        </p:attrNameLst>
+                                      </p:cBhvr>
+                                      <p:to>
+                                        <p:strVal val="visible"/>
+                                      </p:to>
+                                    </p:set>
+                                    <p:set>
+                                      <p:cBhvr>
+                                        <p:cTn id="10" dur="1" fill="hold">
+                                          <p:stCondLst>
+                                            <p:cond delay="0"/>
+                                          </p:stCondLst>
+                                        </p:cTn>
+                                        <p:tgtEl>
+                                          <p:spTgt spid="26"/>
+                                        </p:tgtEl>
+                                        <p:attrNameLst>
+                                          <p:attrName>style.visibility</p:attrName>
+                                        </p:attrNameLst>
+                                      </p:cBhvr>
+                                      <p:to>
+                                        <p:strVal val="visible"/>
+                                      </p:to>
+                                    </p:set>
+                                    <p:set>
+                                      <p:cBhvr>
+                                        <p:cTn id="11" dur="1" fill="hold">
+                                          <p:stCondLst>
+                                            <p:cond delay="0"/>
+                                          </p:stCondLst>
+                                        </p:cTn>
+                                        <p:tgtEl>
+                                          <p:spTgt spid="27"/>
+                                        </p:tgtEl>
+                                        <p:attrNameLst>
+                                          <p:attrName>style.visibility</p:attrName>
+                                        </p:attrNameLst>
+                                      </p:cBhvr>
+                                      <p:to>
+                                        <p:strVal val="visible"/>
+                                      </p:to>
+                                    </p:set>
+                                    <p:set>
+                                      <p:cBhvr>
+                                        <p:cTn id="12" dur="1" fill="hold">
+                                          <p:stCondLst>
+                                            <p:cond delay="0"/>
+                                          </p:stCondLst>
+                                        </p:cTn>
+                                        <p:tgtEl>
+                                          <p:spTgt spid="28"/>
+                                        </p:tgtEl>
+                                        <p:attrNameLst>
+                                          <p:attrName>style.visibility</p:attrName>
+                                        </p:attrNameLst>
+                                      </p:cBhvr>
+                                      <p:to>
+                                        <p:strVal val="visible"/>
+                                      </p:to>
+                                    </p:set>
+                                    <p:set>
+                                      <p:cBhvr>
+                                        <p:cTn id="13" dur="1" fill="hold">
+                                          <p:stCondLst>
+                                            <p:cond delay="0"/>
+                                          </p:stCondLst>
+                                        </p:cTn>
+                                        <p:tgtEl>
+                                          <p:spTgt spid="29"/>
+                                        </p:tgtEl>
+                                        <p:attrNameLst>
+                                          <p:attrName>style.visibility</p:attrName>
+                                        </p:attrNameLst>
+                                      </p:cBhvr>
+                                      <p:to>
+                                        <p:strVal val="visible"/>
+                                      </p:to>
+                                    </p:set>
+                                    <p:set>
+                                      <p:cBhvr>
+                                        <p:cTn id="14" dur="1" fill="hold">
+                                          <p:stCondLst>
+                                            <p:cond delay="0"/>
+                                          </p:stCondLst>
+                                        </p:cTn>
+                                        <p:tgtEl>
+                                          <p:spTgt spid="30"/>
+                                        </p:tgtEl>
+                                        <p:attrNameLst>
+                                          <p:attrName>style.visibility</p:attrName>
+                                        </p:attrNameLst>
+                                      </p:cBhvr>
+                                      <p:to>
+                                        <p:strVal val="visible"/>
+                                      </p:to>
+                                    </p:set>
+                                    <p:set>
+                                      <p:cBhvr>
+                                        <p:cTn id="15" dur="1" fill="hold">
+                                          <p:stCondLst>
+                                            <p:cond delay="0"/>
+                                          </p:stCondLst>
+                                        </p:cTn>
+                                        <p:tgtEl>
+                                          <p:spTgt spid="31"/>
+                                        </p:tgtEl>
+                                        <p:attrNameLst>
+                                          <p:attrName>style.visibility</p:attrName>
+                                        </p:attrNameLst>
+                                      </p:cBhvr>
+                                      <p:to>
+                                        <p:strVal val="visible"/>
+                                      </p:to>
+                                    </p:set>
+                                    <p:set>
+                                      <p:cBhvr>
+                                        <p:cTn id="16" dur="1" fill="hold">
+                                          <p:stCondLst>
+                                            <p:cond delay="0"/>
+                                          </p:stCondLst>
+                                        </p:cTn>
+                                        <p:tgtEl>
+                                          <p:spTgt spid="32"/>
+                                        </p:tgtEl>
+                                        <p:attrNameLst>
+                                          <p:attrName>style.visibility</p:attrName>
+                                        </p:attrNameLst>
+                                      </p:cBhvr>
+                                      <p:to>
+                                        <p:strVal val="visible"/>
+                                      </p:to>
+                                    </p:set>
+                                    <p:set>
+                                      <p:cBhvr>
+                                        <p:cTn id="17" dur="1" fill="hold">
+                                          <p:stCondLst>
+                                            <p:cond delay="0"/>
+                                          </p:stCondLst>
+                                        </p:cTn>
+                                        <p:tgtEl>
+                                          <p:spTgt spid="33"/>
+                                        </p:tgtEl>
+                                        <p:attrNameLst>
+                                          <p:attrName>style.visibility</p:attrName>
+                                        </p:attrNameLst>
+                                      </p:cBhvr>
+                                      <p:to>
+                                        <p:strVal val="visible"/>
+                                      </p:to>
+                                    </p:set>
+                                    <p:set>
+                                      <p:cBhvr>
+                                        <p:cTn id="18" dur="1" fill="hold">
+                                          <p:stCondLst>
+                                            <p:cond delay="0"/>
+                                          </p:stCondLst>
+                                        </p:cTn>
+                                        <p:tgtEl>
+                                          <p:spTgt spid="34"/>
+                                        </p:tgtEl>
+                                        <p:attrNameLst>
+                                          <p:attrName>style.visibility</p:attrName>
+                                        </p:attrNameLst>
+                                      </p:cBhvr>
+                                      <p:to>
+                                        <p:strVal val="visible"/>
+                                      </p:to>
+                                    </p:set>
+                                    <p:set>
+                                      <p:cBhvr>
+                                        <p:cTn id="19" dur="1" fill="hold">
+                                          <p:stCondLst>
+                                            <p:cond delay="0"/>
+                                          </p:stCondLst>
+                                        </p:cTn>
+                                        <p:tgtEl>
+                                          <p:spTgt spid="35"/>
+                                        </p:tgtEl>
+                                        <p:attrNameLst>
+                                          <p:attrName>style.visibility</p:attrName>
+                                        </p:attrNameLst>
+                                      </p:cBhvr>
+                                      <p:to>
+                                        <p:strVal val="visible"/>
+                                      </p:to>
+                                    </p:set>
+                                    <p:set>
+                                      <p:cBhvr>
+                                        <p:cTn id="20" dur="1" fill="hold">
+                                          <p:stCondLst>
+                                            <p:cond delay="0"/>
+                                          </p:stCondLst>
+                                        </p:cTn>
+                                        <p:tgtEl>
+                                          <p:spTgt spid="36"/>
+                                        </p:tgtEl>
+                                        <p:attrNameLst>
+                                          <p:attrName>style.visibility</p:attrName>
+                                        </p:attrNameLst>
+                                      </p:cBhvr>
+                                      <p:to>
+                                        <p:strVal val="visible"/>
+                                      </p:to>
+                                    </p:set>
+                                  </p:childTnLst>
+                                </p:cTn>
+                              </p:par>
                             </p:childTnLst>
                           </p:cTn>
                         </p:par>
@@ -19883,6 +19938,20 @@
                   </p:par>
                 </p:childTnLst>
               </p:cTn>
+              <p:prevCondLst>
+                <p:cond evt="onPrev" delay="0">
+                  <p:tgtEl>
+                    <p:sldTgt/>
+                  </p:tgtEl>
+                </p:cond>
+              </p:prevCondLst>
+              <p:nextCondLst>
+                <p:cond evt="onNext" delay="0">
+                  <p:tgtEl>
+                    <p:sldTgt/>
+                  </p:tgtEl>
+                </p:cond>
+              </p:nextCondLst>
             </p:seq>
           </p:childTnLst>
         </p:cTn>
@@ -20972,281 +21041,290 @@
                       </p:stCondLst>
                       <p:childTnLst>
                         <p:par>
-                          <p:cTn id="4" presetID="2" presetClass="entr" presetSubtype="0" fill="hold" nodeType="clickEffect">
+                          <p:cTn id="4" fill="hold">
                             <p:stCondLst>
                               <p:cond delay="0"/>
                             </p:stCondLst>
                             <p:childTnLst>
-                              <p:set>
-                                <p:cBhvr>
-                                  <p:cTn id="5" dur="1" fill="hold">
-                                    <p:stCondLst>
-                                      <p:cond delay="0"/>
-                                    </p:stCondLst>
-                                  </p:cTn>
-                                  <p:tgtEl>
-                                    <p:spTgt spid="19"/>
-                                  </p:tgtEl>
-                                  <p:attrNameLst>
-                                    <p:attrName>style.visibility</p:attrName>
-                                  </p:attrNameLst>
-                                </p:cBhvr>
-                                <p:to>
-                                  <p:strVal val="visible"/>
-                                </p:to>
-                              </p:set>
-                              <p:set>
-                                <p:cBhvr>
-                                  <p:cTn id="6" dur="1" fill="hold">
-                                    <p:stCondLst>
-                                      <p:cond delay="0"/>
-                                    </p:stCondLst>
-                                  </p:cTn>
-                                  <p:tgtEl>
-                                    <p:spTgt spid="20"/>
-                                  </p:tgtEl>
-                                  <p:attrNameLst>
-                                    <p:attrName>style.visibility</p:attrName>
-                                  </p:attrNameLst>
-                                </p:cBhvr>
-                                <p:to>
-                                  <p:strVal val="visible"/>
-                                </p:to>
-                              </p:set>
-                              <p:set>
-                                <p:cBhvr>
-                                  <p:cTn id="7" dur="1" fill="hold">
-                                    <p:stCondLst>
-                                      <p:cond delay="0"/>
-                                    </p:stCondLst>
-                                  </p:cTn>
-                                  <p:tgtEl>
-                                    <p:spTgt spid="21"/>
-                                  </p:tgtEl>
-                                  <p:attrNameLst>
-                                    <p:attrName>style.visibility</p:attrName>
-                                  </p:attrNameLst>
-                                </p:cBhvr>
-                                <p:to>
-                                  <p:strVal val="visible"/>
-                                </p:to>
-                              </p:set>
-                              <p:set>
-                                <p:cBhvr>
-                                  <p:cTn id="8" dur="1" fill="hold">
-                                    <p:stCondLst>
-                                      <p:cond delay="0"/>
-                                    </p:stCondLst>
-                                  </p:cTn>
-                                  <p:tgtEl>
-                                    <p:spTgt spid="22"/>
-                                  </p:tgtEl>
-                                  <p:attrNameLst>
-                                    <p:attrName>style.visibility</p:attrName>
-                                  </p:attrNameLst>
-                                </p:cBhvr>
-                                <p:to>
-                                  <p:strVal val="visible"/>
-                                </p:to>
-                              </p:set>
-                              <p:set>
-                                <p:cBhvr>
-                                  <p:cTn id="9" dur="1" fill="hold">
-                                    <p:stCondLst>
-                                      <p:cond delay="0"/>
-                                    </p:stCondLst>
-                                  </p:cTn>
-                                  <p:tgtEl>
-                                    <p:spTgt spid="23"/>
-                                  </p:tgtEl>
-                                  <p:attrNameLst>
-                                    <p:attrName>style.visibility</p:attrName>
-                                  </p:attrNameLst>
-                                </p:cBhvr>
-                                <p:to>
-                                  <p:strVal val="visible"/>
-                                </p:to>
-                              </p:set>
-                              <p:set>
-                                <p:cBhvr>
-                                  <p:cTn id="10" dur="1" fill="hold">
-                                    <p:stCondLst>
-                                      <p:cond delay="0"/>
-                                    </p:stCondLst>
-                                  </p:cTn>
-                                  <p:tgtEl>
-                                    <p:spTgt spid="24"/>
-                                  </p:tgtEl>
-                                  <p:attrNameLst>
-                                    <p:attrName>style.visibility</p:attrName>
-                                  </p:attrNameLst>
-                                </p:cBhvr>
-                                <p:to>
-                                  <p:strVal val="visible"/>
-                                </p:to>
-                              </p:set>
-                              <p:set>
-                                <p:cBhvr>
-                                  <p:cTn id="11" dur="1" fill="hold">
-                                    <p:stCondLst>
-                                      <p:cond delay="0"/>
-                                    </p:stCondLst>
-                                  </p:cTn>
-                                  <p:tgtEl>
-                                    <p:spTgt spid="25"/>
-                                  </p:tgtEl>
-                                  <p:attrNameLst>
-                                    <p:attrName>style.visibility</p:attrName>
-                                  </p:attrNameLst>
-                                </p:cBhvr>
-                                <p:to>
-                                  <p:strVal val="visible"/>
-                                </p:to>
-                              </p:set>
-                              <p:set>
-                                <p:cBhvr>
-                                  <p:cTn id="12" dur="1" fill="hold">
-                                    <p:stCondLst>
-                                      <p:cond delay="0"/>
-                                    </p:stCondLst>
-                                  </p:cTn>
-                                  <p:tgtEl>
-                                    <p:spTgt spid="26"/>
-                                  </p:tgtEl>
-                                  <p:attrNameLst>
-                                    <p:attrName>style.visibility</p:attrName>
-                                  </p:attrNameLst>
-                                </p:cBhvr>
-                                <p:to>
-                                  <p:strVal val="visible"/>
-                                </p:to>
-                              </p:set>
-                              <p:set>
-                                <p:cBhvr>
-                                  <p:cTn id="13" dur="1" fill="hold">
-                                    <p:stCondLst>
-                                      <p:cond delay="0"/>
-                                    </p:stCondLst>
-                                  </p:cTn>
-                                  <p:tgtEl>
-                                    <p:spTgt spid="27"/>
-                                  </p:tgtEl>
-                                  <p:attrNameLst>
-                                    <p:attrName>style.visibility</p:attrName>
-                                  </p:attrNameLst>
-                                </p:cBhvr>
-                                <p:to>
-                                  <p:strVal val="visible"/>
-                                </p:to>
-                              </p:set>
-                              <p:set>
-                                <p:cBhvr>
-                                  <p:cTn id="14" dur="1" fill="hold">
-                                    <p:stCondLst>
-                                      <p:cond delay="0"/>
-                                    </p:stCondLst>
-                                  </p:cTn>
-                                  <p:tgtEl>
-                                    <p:spTgt spid="28"/>
-                                  </p:tgtEl>
-                                  <p:attrNameLst>
-                                    <p:attrName>style.visibility</p:attrName>
-                                  </p:attrNameLst>
-                                </p:cBhvr>
-                                <p:to>
-                                  <p:strVal val="visible"/>
-                                </p:to>
-                              </p:set>
-                              <p:set>
-                                <p:cBhvr>
-                                  <p:cTn id="15" dur="1" fill="hold">
-                                    <p:stCondLst>
-                                      <p:cond delay="0"/>
-                                    </p:stCondLst>
-                                  </p:cTn>
-                                  <p:tgtEl>
-                                    <p:spTgt spid="29"/>
-                                  </p:tgtEl>
-                                  <p:attrNameLst>
-                                    <p:attrName>style.visibility</p:attrName>
-                                  </p:attrNameLst>
-                                </p:cBhvr>
-                                <p:to>
-                                  <p:strVal val="visible"/>
-                                </p:to>
-                              </p:set>
-                              <p:set>
-                                <p:cBhvr>
-                                  <p:cTn id="16" dur="1" fill="hold">
-                                    <p:stCondLst>
-                                      <p:cond delay="0"/>
-                                    </p:stCondLst>
-                                  </p:cTn>
-                                  <p:tgtEl>
-                                    <p:spTgt spid="30"/>
-                                  </p:tgtEl>
-                                  <p:attrNameLst>
-                                    <p:attrName>style.visibility</p:attrName>
-                                  </p:attrNameLst>
-                                </p:cBhvr>
-                                <p:to>
-                                  <p:strVal val="visible"/>
-                                </p:to>
-                              </p:set>
-                              <p:set>
-                                <p:cBhvr>
-                                  <p:cTn id="17" dur="1" fill="hold">
-                                    <p:stCondLst>
-                                      <p:cond delay="0"/>
-                                    </p:stCondLst>
-                                  </p:cTn>
-                                  <p:tgtEl>
-                                    <p:spTgt spid="31"/>
-                                  </p:tgtEl>
-                                  <p:attrNameLst>
-                                    <p:attrName>style.visibility</p:attrName>
-                                  </p:attrNameLst>
-                                </p:cBhvr>
-                                <p:to>
-                                  <p:strVal val="visible"/>
-                                </p:to>
-                              </p:set>
-                              <p:set>
-                                <p:cBhvr>
-                                  <p:cTn id="18" dur="1" fill="hold">
-                                    <p:stCondLst>
-                                      <p:cond delay="0"/>
-                                    </p:stCondLst>
-                                  </p:cTn>
-                                  <p:tgtEl>
-                                    <p:spTgt spid="32"/>
-                                  </p:tgtEl>
-                                  <p:attrNameLst>
-                                    <p:attrName>style.visibility</p:attrName>
-                                  </p:attrNameLst>
-                                </p:cBhvr>
-                                <p:to>
-                                  <p:strVal val="visible"/>
-                                </p:to>
-                              </p:set>
-                              <p:set>
-                                <p:cBhvr>
-                                  <p:cTn id="19" dur="1" fill="hold">
-                                    <p:stCondLst>
-                                      <p:cond delay="0"/>
-                                    </p:stCondLst>
-                                  </p:cTn>
-                                  <p:tgtEl>
-                                    <p:spTgt spid="33"/>
-                                  </p:tgtEl>
-                                  <p:attrNameLst>
-                                    <p:attrName>style.visibility</p:attrName>
-                                  </p:attrNameLst>
-                                </p:cBhvr>
-                                <p:to>
-                                  <p:strVal val="visible"/>
-                                </p:to>
-                              </p:set>
+                              <p:par>
+                                <p:cTn id="5" presetID="2" presetClass="entr" presetSubtype="0" fill="hold" grpId="0" nodeType="clickEffect">
+                                  <p:stCondLst>
+                                    <p:cond delay="0"/>
+                                  </p:stCondLst>
+                                  <p:childTnLst>
+                                    <p:set>
+                                      <p:cBhvr>
+                                        <p:cTn id="6" dur="1" fill="hold">
+                                          <p:stCondLst>
+                                            <p:cond delay="0"/>
+                                          </p:stCondLst>
+                                        </p:cTn>
+                                        <p:tgtEl>
+                                          <p:spTgt spid="19"/>
+                                        </p:tgtEl>
+                                        <p:attrNameLst>
+                                          <p:attrName>style.visibility</p:attrName>
+                                        </p:attrNameLst>
+                                      </p:cBhvr>
+                                      <p:to>
+                                        <p:strVal val="visible"/>
+                                      </p:to>
+                                    </p:set>
+                                    <p:set>
+                                      <p:cBhvr>
+                                        <p:cTn id="7" dur="1" fill="hold">
+                                          <p:stCondLst>
+                                            <p:cond delay="0"/>
+                                          </p:stCondLst>
+                                        </p:cTn>
+                                        <p:tgtEl>
+                                          <p:spTgt spid="20"/>
+                                        </p:tgtEl>
+                                        <p:attrNameLst>
+                                          <p:attrName>style.visibility</p:attrName>
+                                        </p:attrNameLst>
+                                      </p:cBhvr>
+                                      <p:to>
+                                        <p:strVal val="visible"/>
+                                      </p:to>
+                                    </p:set>
+                                    <p:set>
+                                      <p:cBhvr>
+                                        <p:cTn id="8" dur="1" fill="hold">
+                                          <p:stCondLst>
+                                            <p:cond delay="0"/>
+                                          </p:stCondLst>
+                                        </p:cTn>
+                                        <p:tgtEl>
+                                          <p:spTgt spid="21"/>
+                                        </p:tgtEl>
+                                        <p:attrNameLst>
+                                          <p:attrName>style.visibility</p:attrName>
+                                        </p:attrNameLst>
+                                      </p:cBhvr>
+                                      <p:to>
+                                        <p:strVal val="visible"/>
+                                      </p:to>
+                                    </p:set>
+                                    <p:set>
+                                      <p:cBhvr>
+                                        <p:cTn id="9" dur="1" fill="hold">
+                                          <p:stCondLst>
+                                            <p:cond delay="0"/>
+                                          </p:stCondLst>
+                                        </p:cTn>
+                                        <p:tgtEl>
+                                          <p:spTgt spid="22"/>
+                                        </p:tgtEl>
+                                        <p:attrNameLst>
+                                          <p:attrName>style.visibility</p:attrName>
+                                        </p:attrNameLst>
+                                      </p:cBhvr>
+                                      <p:to>
+                                        <p:strVal val="visible"/>
+                                      </p:to>
+                                    </p:set>
+                                    <p:set>
+                                      <p:cBhvr>
+                                        <p:cTn id="10" dur="1" fill="hold">
+                                          <p:stCondLst>
+                                            <p:cond delay="0"/>
+                                          </p:stCondLst>
+                                        </p:cTn>
+                                        <p:tgtEl>
+                                          <p:spTgt spid="23"/>
+                                        </p:tgtEl>
+                                        <p:attrNameLst>
+                                          <p:attrName>style.visibility</p:attrName>
+                                        </p:attrNameLst>
+                                      </p:cBhvr>
+                                      <p:to>
+                                        <p:strVal val="visible"/>
+                                      </p:to>
+                                    </p:set>
+                                    <p:set>
+                                      <p:cBhvr>
+                                        <p:cTn id="11" dur="1" fill="hold">
+                                          <p:stCondLst>
+                                            <p:cond delay="0"/>
+                                          </p:stCondLst>
+                                        </p:cTn>
+                                        <p:tgtEl>
+                                          <p:spTgt spid="24"/>
+                                        </p:tgtEl>
+                                        <p:attrNameLst>
+                                          <p:attrName>style.visibility</p:attrName>
+                                        </p:attrNameLst>
+                                      </p:cBhvr>
+                                      <p:to>
+                                        <p:strVal val="visible"/>
+                                      </p:to>
+                                    </p:set>
+                                    <p:set>
+                                      <p:cBhvr>
+                                        <p:cTn id="12" dur="1" fill="hold">
+                                          <p:stCondLst>
+                                            <p:cond delay="0"/>
+                                          </p:stCondLst>
+                                        </p:cTn>
+                                        <p:tgtEl>
+                                          <p:spTgt spid="25"/>
+                                        </p:tgtEl>
+                                        <p:attrNameLst>
+                                          <p:attrName>style.visibility</p:attrName>
+                                        </p:attrNameLst>
+                                      </p:cBhvr>
+                                      <p:to>
+                                        <p:strVal val="visible"/>
+                                      </p:to>
+                                    </p:set>
+                                    <p:set>
+                                      <p:cBhvr>
+                                        <p:cTn id="13" dur="1" fill="hold">
+                                          <p:stCondLst>
+                                            <p:cond delay="0"/>
+                                          </p:stCondLst>
+                                        </p:cTn>
+                                        <p:tgtEl>
+                                          <p:spTgt spid="26"/>
+                                        </p:tgtEl>
+                                        <p:attrNameLst>
+                                          <p:attrName>style.visibility</p:attrName>
+                                        </p:attrNameLst>
+                                      </p:cBhvr>
+                                      <p:to>
+                                        <p:strVal val="visible"/>
+                                      </p:to>
+                                    </p:set>
+                                    <p:set>
+                                      <p:cBhvr>
+                                        <p:cTn id="14" dur="1" fill="hold">
+                                          <p:stCondLst>
+                                            <p:cond delay="0"/>
+                                          </p:stCondLst>
+                                        </p:cTn>
+                                        <p:tgtEl>
+                                          <p:spTgt spid="27"/>
+                                        </p:tgtEl>
+                                        <p:attrNameLst>
+                                          <p:attrName>style.visibility</p:attrName>
+                                        </p:attrNameLst>
+                                      </p:cBhvr>
+                                      <p:to>
+                                        <p:strVal val="visible"/>
+                                      </p:to>
+                                    </p:set>
+                                    <p:set>
+                                      <p:cBhvr>
+                                        <p:cTn id="15" dur="1" fill="hold">
+                                          <p:stCondLst>
+                                            <p:cond delay="0"/>
+                                          </p:stCondLst>
+                                        </p:cTn>
+                                        <p:tgtEl>
+                                          <p:spTgt spid="28"/>
+                                        </p:tgtEl>
+                                        <p:attrNameLst>
+                                          <p:attrName>style.visibility</p:attrName>
+                                        </p:attrNameLst>
+                                      </p:cBhvr>
+                                      <p:to>
+                                        <p:strVal val="visible"/>
+                                      </p:to>
+                                    </p:set>
+                                    <p:set>
+                                      <p:cBhvr>
+                                        <p:cTn id="16" dur="1" fill="hold">
+                                          <p:stCondLst>
+                                            <p:cond delay="0"/>
+                                          </p:stCondLst>
+                                        </p:cTn>
+                                        <p:tgtEl>
+                                          <p:spTgt spid="29"/>
+                                        </p:tgtEl>
+                                        <p:attrNameLst>
+                                          <p:attrName>style.visibility</p:attrName>
+                                        </p:attrNameLst>
+                                      </p:cBhvr>
+                                      <p:to>
+                                        <p:strVal val="visible"/>
+                                      </p:to>
+                                    </p:set>
+                                    <p:set>
+                                      <p:cBhvr>
+                                        <p:cTn id="17" dur="1" fill="hold">
+                                          <p:stCondLst>
+                                            <p:cond delay="0"/>
+                                          </p:stCondLst>
+                                        </p:cTn>
+                                        <p:tgtEl>
+                                          <p:spTgt spid="30"/>
+                                        </p:tgtEl>
+                                        <p:attrNameLst>
+                                          <p:attrName>style.visibility</p:attrName>
+                                        </p:attrNameLst>
+                                      </p:cBhvr>
+                                      <p:to>
+                                        <p:strVal val="visible"/>
+                                      </p:to>
+                                    </p:set>
+                                    <p:set>
+                                      <p:cBhvr>
+                                        <p:cTn id="18" dur="1" fill="hold">
+                                          <p:stCondLst>
+                                            <p:cond delay="0"/>
+                                          </p:stCondLst>
+                                        </p:cTn>
+                                        <p:tgtEl>
+                                          <p:spTgt spid="31"/>
+                                        </p:tgtEl>
+                                        <p:attrNameLst>
+                                          <p:attrName>style.visibility</p:attrName>
+                                        </p:attrNameLst>
+                                      </p:cBhvr>
+                                      <p:to>
+                                        <p:strVal val="visible"/>
+                                      </p:to>
+                                    </p:set>
+                                    <p:set>
+                                      <p:cBhvr>
+                                        <p:cTn id="19" dur="1" fill="hold">
+                                          <p:stCondLst>
+                                            <p:cond delay="0"/>
+                                          </p:stCondLst>
+                                        </p:cTn>
+                                        <p:tgtEl>
+                                          <p:spTgt spid="32"/>
+                                        </p:tgtEl>
+                                        <p:attrNameLst>
+                                          <p:attrName>style.visibility</p:attrName>
+                                        </p:attrNameLst>
+                                      </p:cBhvr>
+                                      <p:to>
+                                        <p:strVal val="visible"/>
+                                      </p:to>
+                                    </p:set>
+                                    <p:set>
+                                      <p:cBhvr>
+                                        <p:cTn id="20" dur="1" fill="hold">
+                                          <p:stCondLst>
+                                            <p:cond delay="0"/>
+                                          </p:stCondLst>
+                                        </p:cTn>
+                                        <p:tgtEl>
+                                          <p:spTgt spid="33"/>
+                                        </p:tgtEl>
+                                        <p:attrNameLst>
+                                          <p:attrName>style.visibility</p:attrName>
+                                        </p:attrNameLst>
+                                      </p:cBhvr>
+                                      <p:to>
+                                        <p:strVal val="visible"/>
+                                      </p:to>
+                                    </p:set>
+                                  </p:childTnLst>
+                                </p:cTn>
+                              </p:par>
                             </p:childTnLst>
                           </p:cTn>
                         </p:par>
@@ -21255,6 +21333,20 @@
                   </p:par>
                 </p:childTnLst>
               </p:cTn>
+              <p:prevCondLst>
+                <p:cond evt="onPrev" delay="0">
+                  <p:tgtEl>
+                    <p:sldTgt/>
+                  </p:tgtEl>
+                </p:cond>
+              </p:prevCondLst>
+              <p:nextCondLst>
+                <p:cond evt="onNext" delay="0">
+                  <p:tgtEl>
+                    <p:sldTgt/>
+                  </p:tgtEl>
+                </p:cond>
+              </p:nextCondLst>
             </p:seq>
           </p:childTnLst>
         </p:cTn>
@@ -22405,281 +22497,290 @@
                       </p:stCondLst>
                       <p:childTnLst>
                         <p:par>
-                          <p:cTn id="4" presetID="2" presetClass="entr" presetSubtype="0" fill="hold" nodeType="clickEffect">
+                          <p:cTn id="4" fill="hold">
                             <p:stCondLst>
                               <p:cond delay="0"/>
                             </p:stCondLst>
                             <p:childTnLst>
-                              <p:set>
-                                <p:cBhvr>
-                                  <p:cTn id="5" dur="1" fill="hold">
-                                    <p:stCondLst>
-                                      <p:cond delay="0"/>
-                                    </p:stCondLst>
-                                  </p:cTn>
-                                  <p:tgtEl>
-                                    <p:spTgt spid="21"/>
-                                  </p:tgtEl>
-                                  <p:attrNameLst>
-                                    <p:attrName>style.visibility</p:attrName>
-                                  </p:attrNameLst>
-                                </p:cBhvr>
-                                <p:to>
-                                  <p:strVal val="visible"/>
-                                </p:to>
-                              </p:set>
-                              <p:set>
-                                <p:cBhvr>
-                                  <p:cTn id="6" dur="1" fill="hold">
-                                    <p:stCondLst>
-                                      <p:cond delay="0"/>
-                                    </p:stCondLst>
-                                  </p:cTn>
-                                  <p:tgtEl>
-                                    <p:spTgt spid="22"/>
-                                  </p:tgtEl>
-                                  <p:attrNameLst>
-                                    <p:attrName>style.visibility</p:attrName>
-                                  </p:attrNameLst>
-                                </p:cBhvr>
-                                <p:to>
-                                  <p:strVal val="visible"/>
-                                </p:to>
-                              </p:set>
-                              <p:set>
-                                <p:cBhvr>
-                                  <p:cTn id="7" dur="1" fill="hold">
-                                    <p:stCondLst>
-                                      <p:cond delay="0"/>
-                                    </p:stCondLst>
-                                  </p:cTn>
-                                  <p:tgtEl>
-                                    <p:spTgt spid="23"/>
-                                  </p:tgtEl>
-                                  <p:attrNameLst>
-                                    <p:attrName>style.visibility</p:attrName>
-                                  </p:attrNameLst>
-                                </p:cBhvr>
-                                <p:to>
-                                  <p:strVal val="visible"/>
-                                </p:to>
-                              </p:set>
-                              <p:set>
-                                <p:cBhvr>
-                                  <p:cTn id="8" dur="1" fill="hold">
-                                    <p:stCondLst>
-                                      <p:cond delay="0"/>
-                                    </p:stCondLst>
-                                  </p:cTn>
-                                  <p:tgtEl>
-                                    <p:spTgt spid="24"/>
-                                  </p:tgtEl>
-                                  <p:attrNameLst>
-                                    <p:attrName>style.visibility</p:attrName>
-                                  </p:attrNameLst>
-                                </p:cBhvr>
-                                <p:to>
-                                  <p:strVal val="visible"/>
-                                </p:to>
-                              </p:set>
-                              <p:set>
-                                <p:cBhvr>
-                                  <p:cTn id="9" dur="1" fill="hold">
-                                    <p:stCondLst>
-                                      <p:cond delay="0"/>
-                                    </p:stCondLst>
-                                  </p:cTn>
-                                  <p:tgtEl>
-                                    <p:spTgt spid="25"/>
-                                  </p:tgtEl>
-                                  <p:attrNameLst>
-                                    <p:attrName>style.visibility</p:attrName>
-                                  </p:attrNameLst>
-                                </p:cBhvr>
-                                <p:to>
-                                  <p:strVal val="visible"/>
-                                </p:to>
-                              </p:set>
-                              <p:set>
-                                <p:cBhvr>
-                                  <p:cTn id="10" dur="1" fill="hold">
-                                    <p:stCondLst>
-                                      <p:cond delay="0"/>
-                                    </p:stCondLst>
-                                  </p:cTn>
-                                  <p:tgtEl>
-                                    <p:spTgt spid="26"/>
-                                  </p:tgtEl>
-                                  <p:attrNameLst>
-                                    <p:attrName>style.visibility</p:attrName>
-                                  </p:attrNameLst>
-                                </p:cBhvr>
-                                <p:to>
-                                  <p:strVal val="visible"/>
-                                </p:to>
-                              </p:set>
-                              <p:set>
-                                <p:cBhvr>
-                                  <p:cTn id="11" dur="1" fill="hold">
-                                    <p:stCondLst>
-                                      <p:cond delay="0"/>
-                                    </p:stCondLst>
-                                  </p:cTn>
-                                  <p:tgtEl>
-                                    <p:spTgt spid="27"/>
-                                  </p:tgtEl>
-                                  <p:attrNameLst>
-                                    <p:attrName>style.visibility</p:attrName>
-                                  </p:attrNameLst>
-                                </p:cBhvr>
-                                <p:to>
-                                  <p:strVal val="visible"/>
-                                </p:to>
-                              </p:set>
-                              <p:set>
-                                <p:cBhvr>
-                                  <p:cTn id="12" dur="1" fill="hold">
-                                    <p:stCondLst>
-                                      <p:cond delay="0"/>
-                                    </p:stCondLst>
-                                  </p:cTn>
-                                  <p:tgtEl>
-                                    <p:spTgt spid="28"/>
-                                  </p:tgtEl>
-                                  <p:attrNameLst>
-                                    <p:attrName>style.visibility</p:attrName>
-                                  </p:attrNameLst>
-                                </p:cBhvr>
-                                <p:to>
-                                  <p:strVal val="visible"/>
-                                </p:to>
-                              </p:set>
-                              <p:set>
-                                <p:cBhvr>
-                                  <p:cTn id="13" dur="1" fill="hold">
-                                    <p:stCondLst>
-                                      <p:cond delay="0"/>
-                                    </p:stCondLst>
-                                  </p:cTn>
-                                  <p:tgtEl>
-                                    <p:spTgt spid="29"/>
-                                  </p:tgtEl>
-                                  <p:attrNameLst>
-                                    <p:attrName>style.visibility</p:attrName>
-                                  </p:attrNameLst>
-                                </p:cBhvr>
-                                <p:to>
-                                  <p:strVal val="visible"/>
-                                </p:to>
-                              </p:set>
-                              <p:set>
-                                <p:cBhvr>
-                                  <p:cTn id="14" dur="1" fill="hold">
-                                    <p:stCondLst>
-                                      <p:cond delay="0"/>
-                                    </p:stCondLst>
-                                  </p:cTn>
-                                  <p:tgtEl>
-                                    <p:spTgt spid="30"/>
-                                  </p:tgtEl>
-                                  <p:attrNameLst>
-                                    <p:attrName>style.visibility</p:attrName>
-                                  </p:attrNameLst>
-                                </p:cBhvr>
-                                <p:to>
-                                  <p:strVal val="visible"/>
-                                </p:to>
-                              </p:set>
-                              <p:set>
-                                <p:cBhvr>
-                                  <p:cTn id="15" dur="1" fill="hold">
-                                    <p:stCondLst>
-                                      <p:cond delay="0"/>
-                                    </p:stCondLst>
-                                  </p:cTn>
-                                  <p:tgtEl>
-                                    <p:spTgt spid="31"/>
-                                  </p:tgtEl>
-                                  <p:attrNameLst>
-                                    <p:attrName>style.visibility</p:attrName>
-                                  </p:attrNameLst>
-                                </p:cBhvr>
-                                <p:to>
-                                  <p:strVal val="visible"/>
-                                </p:to>
-                              </p:set>
-                              <p:set>
-                                <p:cBhvr>
-                                  <p:cTn id="16" dur="1" fill="hold">
-                                    <p:stCondLst>
-                                      <p:cond delay="0"/>
-                                    </p:stCondLst>
-                                  </p:cTn>
-                                  <p:tgtEl>
-                                    <p:spTgt spid="32"/>
-                                  </p:tgtEl>
-                                  <p:attrNameLst>
-                                    <p:attrName>style.visibility</p:attrName>
-                                  </p:attrNameLst>
-                                </p:cBhvr>
-                                <p:to>
-                                  <p:strVal val="visible"/>
-                                </p:to>
-                              </p:set>
-                              <p:set>
-                                <p:cBhvr>
-                                  <p:cTn id="17" dur="1" fill="hold">
-                                    <p:stCondLst>
-                                      <p:cond delay="0"/>
-                                    </p:stCondLst>
-                                  </p:cTn>
-                                  <p:tgtEl>
-                                    <p:spTgt spid="33"/>
-                                  </p:tgtEl>
-                                  <p:attrNameLst>
-                                    <p:attrName>style.visibility</p:attrName>
-                                  </p:attrNameLst>
-                                </p:cBhvr>
-                                <p:to>
-                                  <p:strVal val="visible"/>
-                                </p:to>
-                              </p:set>
-                              <p:set>
-                                <p:cBhvr>
-                                  <p:cTn id="18" dur="1" fill="hold">
-                                    <p:stCondLst>
-                                      <p:cond delay="0"/>
-                                    </p:stCondLst>
-                                  </p:cTn>
-                                  <p:tgtEl>
-                                    <p:spTgt spid="34"/>
-                                  </p:tgtEl>
-                                  <p:attrNameLst>
-                                    <p:attrName>style.visibility</p:attrName>
-                                  </p:attrNameLst>
-                                </p:cBhvr>
-                                <p:to>
-                                  <p:strVal val="visible"/>
-                                </p:to>
-                              </p:set>
-                              <p:set>
-                                <p:cBhvr>
-                                  <p:cTn id="19" dur="1" fill="hold">
-                                    <p:stCondLst>
-                                      <p:cond delay="0"/>
-                                    </p:stCondLst>
-                                  </p:cTn>
-                                  <p:tgtEl>
-                                    <p:spTgt spid="35"/>
-                                  </p:tgtEl>
-                                  <p:attrNameLst>
-                                    <p:attrName>style.visibility</p:attrName>
-                                  </p:attrNameLst>
-                                </p:cBhvr>
-                                <p:to>
-                                  <p:strVal val="visible"/>
-                                </p:to>
-                              </p:set>
+                              <p:par>
+                                <p:cTn id="5" presetID="2" presetClass="entr" presetSubtype="0" fill="hold" grpId="0" nodeType="clickEffect">
+                                  <p:stCondLst>
+                                    <p:cond delay="0"/>
+                                  </p:stCondLst>
+                                  <p:childTnLst>
+                                    <p:set>
+                                      <p:cBhvr>
+                                        <p:cTn id="6" dur="1" fill="hold">
+                                          <p:stCondLst>
+                                            <p:cond delay="0"/>
+                                          </p:stCondLst>
+                                        </p:cTn>
+                                        <p:tgtEl>
+                                          <p:spTgt spid="21"/>
+                                        </p:tgtEl>
+                                        <p:attrNameLst>
+                                          <p:attrName>style.visibility</p:attrName>
+                                        </p:attrNameLst>
+                                      </p:cBhvr>
+                                      <p:to>
+                                        <p:strVal val="visible"/>
+                                      </p:to>
+                                    </p:set>
+                                    <p:set>
+                                      <p:cBhvr>
+                                        <p:cTn id="7" dur="1" fill="hold">
+                                          <p:stCondLst>
+                                            <p:cond delay="0"/>
+                                          </p:stCondLst>
+                                        </p:cTn>
+                                        <p:tgtEl>
+                                          <p:spTgt spid="22"/>
+                                        </p:tgtEl>
+                                        <p:attrNameLst>
+                                          <p:attrName>style.visibility</p:attrName>
+                                        </p:attrNameLst>
+                                      </p:cBhvr>
+                                      <p:to>
+                                        <p:strVal val="visible"/>
+                                      </p:to>
+                                    </p:set>
+                                    <p:set>
+                                      <p:cBhvr>
+                                        <p:cTn id="8" dur="1" fill="hold">
+                                          <p:stCondLst>
+                                            <p:cond delay="0"/>
+                                          </p:stCondLst>
+                                        </p:cTn>
+                                        <p:tgtEl>
+                                          <p:spTgt spid="23"/>
+                                        </p:tgtEl>
+                                        <p:attrNameLst>
+                                          <p:attrName>style.visibility</p:attrName>
+                                        </p:attrNameLst>
+                                      </p:cBhvr>
+                                      <p:to>
+                                        <p:strVal val="visible"/>
+                                      </p:to>
+                                    </p:set>
+                                    <p:set>
+                                      <p:cBhvr>
+                                        <p:cTn id="9" dur="1" fill="hold">
+                                          <p:stCondLst>
+                                            <p:cond delay="0"/>
+                                          </p:stCondLst>
+                                        </p:cTn>
+                                        <p:tgtEl>
+                                          <p:spTgt spid="24"/>
+                                        </p:tgtEl>
+                                        <p:attrNameLst>
+                                          <p:attrName>style.visibility</p:attrName>
+                                        </p:attrNameLst>
+                                      </p:cBhvr>
+                                      <p:to>
+                                        <p:strVal val="visible"/>
+                                      </p:to>
+                                    </p:set>
+                                    <p:set>
+                                      <p:cBhvr>
+                                        <p:cTn id="10" dur="1" fill="hold">
+                                          <p:stCondLst>
+                                            <p:cond delay="0"/>
+                                          </p:stCondLst>
+                                        </p:cTn>
+                                        <p:tgtEl>
+                                          <p:spTgt spid="25"/>
+                                        </p:tgtEl>
+                                        <p:attrNameLst>
+                                          <p:attrName>style.visibility</p:attrName>
+                                        </p:attrNameLst>
+                                      </p:cBhvr>
+                                      <p:to>
+                                        <p:strVal val="visible"/>
+                                      </p:to>
+                                    </p:set>
+                                    <p:set>
+                                      <p:cBhvr>
+                                        <p:cTn id="11" dur="1" fill="hold">
+                                          <p:stCondLst>
+                                            <p:cond delay="0"/>
+                                          </p:stCondLst>
+                                        </p:cTn>
+                                        <p:tgtEl>
+                                          <p:spTgt spid="26"/>
+                                        </p:tgtEl>
+                                        <p:attrNameLst>
+                                          <p:attrName>style.visibility</p:attrName>
+                                        </p:attrNameLst>
+                                      </p:cBhvr>
+                                      <p:to>
+                                        <p:strVal val="visible"/>
+                                      </p:to>
+                                    </p:set>
+                                    <p:set>
+                                      <p:cBhvr>
+                                        <p:cTn id="12" dur="1" fill="hold">
+                                          <p:stCondLst>
+                                            <p:cond delay="0"/>
+                                          </p:stCondLst>
+                                        </p:cTn>
+                                        <p:tgtEl>
+                                          <p:spTgt spid="27"/>
+                                        </p:tgtEl>
+                                        <p:attrNameLst>
+                                          <p:attrName>style.visibility</p:attrName>
+                                        </p:attrNameLst>
+                                      </p:cBhvr>
+                                      <p:to>
+                                        <p:strVal val="visible"/>
+                                      </p:to>
+                                    </p:set>
+                                    <p:set>
+                                      <p:cBhvr>
+                                        <p:cTn id="13" dur="1" fill="hold">
+                                          <p:stCondLst>
+                                            <p:cond delay="0"/>
+                                          </p:stCondLst>
+                                        </p:cTn>
+                                        <p:tgtEl>
+                                          <p:spTgt spid="28"/>
+                                        </p:tgtEl>
+                                        <p:attrNameLst>
+                                          <p:attrName>style.visibility</p:attrName>
+                                        </p:attrNameLst>
+                                      </p:cBhvr>
+                                      <p:to>
+                                        <p:strVal val="visible"/>
+                                      </p:to>
+                                    </p:set>
+                                    <p:set>
+                                      <p:cBhvr>
+                                        <p:cTn id="14" dur="1" fill="hold">
+                                          <p:stCondLst>
+                                            <p:cond delay="0"/>
+                                          </p:stCondLst>
+                                        </p:cTn>
+                                        <p:tgtEl>
+                                          <p:spTgt spid="29"/>
+                                        </p:tgtEl>
+                                        <p:attrNameLst>
+                                          <p:attrName>style.visibility</p:attrName>
+                                        </p:attrNameLst>
+                                      </p:cBhvr>
+                                      <p:to>
+                                        <p:strVal val="visible"/>
+                                      </p:to>
+                                    </p:set>
+                                    <p:set>
+                                      <p:cBhvr>
+                                        <p:cTn id="15" dur="1" fill="hold">
+                                          <p:stCondLst>
+                                            <p:cond delay="0"/>
+                                          </p:stCondLst>
+                                        </p:cTn>
+                                        <p:tgtEl>
+                                          <p:spTgt spid="30"/>
+                                        </p:tgtEl>
+                                        <p:attrNameLst>
+                                          <p:attrName>style.visibility</p:attrName>
+                                        </p:attrNameLst>
+                                      </p:cBhvr>
+                                      <p:to>
+                                        <p:strVal val="visible"/>
+                                      </p:to>
+                                    </p:set>
+                                    <p:set>
+                                      <p:cBhvr>
+                                        <p:cTn id="16" dur="1" fill="hold">
+                                          <p:stCondLst>
+                                            <p:cond delay="0"/>
+                                          </p:stCondLst>
+                                        </p:cTn>
+                                        <p:tgtEl>
+                                          <p:spTgt spid="31"/>
+                                        </p:tgtEl>
+                                        <p:attrNameLst>
+                                          <p:attrName>style.visibility</p:attrName>
+                                        </p:attrNameLst>
+                                      </p:cBhvr>
+                                      <p:to>
+                                        <p:strVal val="visible"/>
+                                      </p:to>
+                                    </p:set>
+                                    <p:set>
+                                      <p:cBhvr>
+                                        <p:cTn id="17" dur="1" fill="hold">
+                                          <p:stCondLst>
+                                            <p:cond delay="0"/>
+                                          </p:stCondLst>
+                                        </p:cTn>
+                                        <p:tgtEl>
+                                          <p:spTgt spid="32"/>
+                                        </p:tgtEl>
+                                        <p:attrNameLst>
+                                          <p:attrName>style.visibility</p:attrName>
+                                        </p:attrNameLst>
+                                      </p:cBhvr>
+                                      <p:to>
+                                        <p:strVal val="visible"/>
+                                      </p:to>
+                                    </p:set>
+                                    <p:set>
+                                      <p:cBhvr>
+                                        <p:cTn id="18" dur="1" fill="hold">
+                                          <p:stCondLst>
+                                            <p:cond delay="0"/>
+                                          </p:stCondLst>
+                                        </p:cTn>
+                                        <p:tgtEl>
+                                          <p:spTgt spid="33"/>
+                                        </p:tgtEl>
+                                        <p:attrNameLst>
+                                          <p:attrName>style.visibility</p:attrName>
+                                        </p:attrNameLst>
+                                      </p:cBhvr>
+                                      <p:to>
+                                        <p:strVal val="visible"/>
+                                      </p:to>
+                                    </p:set>
+                                    <p:set>
+                                      <p:cBhvr>
+                                        <p:cTn id="19" dur="1" fill="hold">
+                                          <p:stCondLst>
+                                            <p:cond delay="0"/>
+                                          </p:stCondLst>
+                                        </p:cTn>
+                                        <p:tgtEl>
+                                          <p:spTgt spid="34"/>
+                                        </p:tgtEl>
+                                        <p:attrNameLst>
+                                          <p:attrName>style.visibility</p:attrName>
+                                        </p:attrNameLst>
+                                      </p:cBhvr>
+                                      <p:to>
+                                        <p:strVal val="visible"/>
+                                      </p:to>
+                                    </p:set>
+                                    <p:set>
+                                      <p:cBhvr>
+                                        <p:cTn id="20" dur="1" fill="hold">
+                                          <p:stCondLst>
+                                            <p:cond delay="0"/>
+                                          </p:stCondLst>
+                                        </p:cTn>
+                                        <p:tgtEl>
+                                          <p:spTgt spid="35"/>
+                                        </p:tgtEl>
+                                        <p:attrNameLst>
+                                          <p:attrName>style.visibility</p:attrName>
+                                        </p:attrNameLst>
+                                      </p:cBhvr>
+                                      <p:to>
+                                        <p:strVal val="visible"/>
+                                      </p:to>
+                                    </p:set>
+                                  </p:childTnLst>
+                                </p:cTn>
+                              </p:par>
                             </p:childTnLst>
                           </p:cTn>
                         </p:par>
@@ -22688,6 +22789,20 @@
                   </p:par>
                 </p:childTnLst>
               </p:cTn>
+              <p:prevCondLst>
+                <p:cond evt="onPrev" delay="0">
+                  <p:tgtEl>
+                    <p:sldTgt/>
+                  </p:tgtEl>
+                </p:cond>
+              </p:prevCondLst>
+              <p:nextCondLst>
+                <p:cond evt="onNext" delay="0">
+                  <p:tgtEl>
+                    <p:sldTgt/>
+                  </p:tgtEl>
+                </p:cond>
+              </p:nextCondLst>
             </p:seq>
           </p:childTnLst>
         </p:cTn>
@@ -23838,281 +23953,290 @@
                       </p:stCondLst>
                       <p:childTnLst>
                         <p:par>
-                          <p:cTn id="4" presetID="2" presetClass="entr" presetSubtype="0" fill="hold" nodeType="clickEffect">
+                          <p:cTn id="4" fill="hold">
                             <p:stCondLst>
                               <p:cond delay="0"/>
                             </p:stCondLst>
                             <p:childTnLst>
-                              <p:set>
-                                <p:cBhvr>
-                                  <p:cTn id="5" dur="1" fill="hold">
-                                    <p:stCondLst>
-                                      <p:cond delay="0"/>
-                                    </p:stCondLst>
-                                  </p:cTn>
-                                  <p:tgtEl>
-                                    <p:spTgt spid="21"/>
-                                  </p:tgtEl>
-                                  <p:attrNameLst>
-                                    <p:attrName>style.visibility</p:attrName>
-                                  </p:attrNameLst>
-                                </p:cBhvr>
-                                <p:to>
-                                  <p:strVal val="visible"/>
-                                </p:to>
-                              </p:set>
-                              <p:set>
-                                <p:cBhvr>
-                                  <p:cTn id="6" dur="1" fill="hold">
-                                    <p:stCondLst>
-                                      <p:cond delay="0"/>
-                                    </p:stCondLst>
-                                  </p:cTn>
-                                  <p:tgtEl>
-                                    <p:spTgt spid="22"/>
-                                  </p:tgtEl>
-                                  <p:attrNameLst>
-                                    <p:attrName>style.visibility</p:attrName>
-                                  </p:attrNameLst>
-                                </p:cBhvr>
-                                <p:to>
-                                  <p:strVal val="visible"/>
-                                </p:to>
-                              </p:set>
-                              <p:set>
-                                <p:cBhvr>
-                                  <p:cTn id="7" dur="1" fill="hold">
-                                    <p:stCondLst>
-                                      <p:cond delay="0"/>
-                                    </p:stCondLst>
-                                  </p:cTn>
-                                  <p:tgtEl>
-                                    <p:spTgt spid="23"/>
-                                  </p:tgtEl>
-                                  <p:attrNameLst>
-                                    <p:attrName>style.visibility</p:attrName>
-                                  </p:attrNameLst>
-                                </p:cBhvr>
-                                <p:to>
-                                  <p:strVal val="visible"/>
-                                </p:to>
-                              </p:set>
-                              <p:set>
-                                <p:cBhvr>
-                                  <p:cTn id="8" dur="1" fill="hold">
-                                    <p:stCondLst>
-                                      <p:cond delay="0"/>
-                                    </p:stCondLst>
-                                  </p:cTn>
-                                  <p:tgtEl>
-                                    <p:spTgt spid="24"/>
-                                  </p:tgtEl>
-                                  <p:attrNameLst>
-                                    <p:attrName>style.visibility</p:attrName>
-                                  </p:attrNameLst>
-                                </p:cBhvr>
-                                <p:to>
-                                  <p:strVal val="visible"/>
-                                </p:to>
-                              </p:set>
-                              <p:set>
-                                <p:cBhvr>
-                                  <p:cTn id="9" dur="1" fill="hold">
-                                    <p:stCondLst>
-                                      <p:cond delay="0"/>
-                                    </p:stCondLst>
-                                  </p:cTn>
-                                  <p:tgtEl>
-                                    <p:spTgt spid="25"/>
-                                  </p:tgtEl>
-                                  <p:attrNameLst>
-                                    <p:attrName>style.visibility</p:attrName>
-                                  </p:attrNameLst>
-                                </p:cBhvr>
-                                <p:to>
-                                  <p:strVal val="visible"/>
-                                </p:to>
-                              </p:set>
-                              <p:set>
-                                <p:cBhvr>
-                                  <p:cTn id="10" dur="1" fill="hold">
-                                    <p:stCondLst>
-                                      <p:cond delay="0"/>
-                                    </p:stCondLst>
-                                  </p:cTn>
-                                  <p:tgtEl>
-                                    <p:spTgt spid="26"/>
-                                  </p:tgtEl>
-                                  <p:attrNameLst>
-                                    <p:attrName>style.visibility</p:attrName>
-                                  </p:attrNameLst>
-                                </p:cBhvr>
-                                <p:to>
-                                  <p:strVal val="visible"/>
-                                </p:to>
-                              </p:set>
-                              <p:set>
-                                <p:cBhvr>
-                                  <p:cTn id="11" dur="1" fill="hold">
-                                    <p:stCondLst>
-                                      <p:cond delay="0"/>
-                                    </p:stCondLst>
-                                  </p:cTn>
-                                  <p:tgtEl>
-                                    <p:spTgt spid="27"/>
-                                  </p:tgtEl>
-                                  <p:attrNameLst>
-                                    <p:attrName>style.visibility</p:attrName>
-                                  </p:attrNameLst>
-                                </p:cBhvr>
-                                <p:to>
-                                  <p:strVal val="visible"/>
-                                </p:to>
-                              </p:set>
-                              <p:set>
-                                <p:cBhvr>
-                                  <p:cTn id="12" dur="1" fill="hold">
-                                    <p:stCondLst>
-                                      <p:cond delay="0"/>
-                                    </p:stCondLst>
-                                  </p:cTn>
-                                  <p:tgtEl>
-                                    <p:spTgt spid="28"/>
-                                  </p:tgtEl>
-                                  <p:attrNameLst>
-                                    <p:attrName>style.visibility</p:attrName>
-                                  </p:attrNameLst>
-                                </p:cBhvr>
-                                <p:to>
-                                  <p:strVal val="visible"/>
-                                </p:to>
-                              </p:set>
-                              <p:set>
-                                <p:cBhvr>
-                                  <p:cTn id="13" dur="1" fill="hold">
-                                    <p:stCondLst>
-                                      <p:cond delay="0"/>
-                                    </p:stCondLst>
-                                  </p:cTn>
-                                  <p:tgtEl>
-                                    <p:spTgt spid="29"/>
-                                  </p:tgtEl>
-                                  <p:attrNameLst>
-                                    <p:attrName>style.visibility</p:attrName>
-                                  </p:attrNameLst>
-                                </p:cBhvr>
-                                <p:to>
-                                  <p:strVal val="visible"/>
-                                </p:to>
-                              </p:set>
-                              <p:set>
-                                <p:cBhvr>
-                                  <p:cTn id="14" dur="1" fill="hold">
-                                    <p:stCondLst>
-                                      <p:cond delay="0"/>
-                                    </p:stCondLst>
-                                  </p:cTn>
-                                  <p:tgtEl>
-                                    <p:spTgt spid="30"/>
-                                  </p:tgtEl>
-                                  <p:attrNameLst>
-                                    <p:attrName>style.visibility</p:attrName>
-                                  </p:attrNameLst>
-                                </p:cBhvr>
-                                <p:to>
-                                  <p:strVal val="visible"/>
-                                </p:to>
-                              </p:set>
-                              <p:set>
-                                <p:cBhvr>
-                                  <p:cTn id="15" dur="1" fill="hold">
-                                    <p:stCondLst>
-                                      <p:cond delay="0"/>
-                                    </p:stCondLst>
-                                  </p:cTn>
-                                  <p:tgtEl>
-                                    <p:spTgt spid="31"/>
-                                  </p:tgtEl>
-                                  <p:attrNameLst>
-                                    <p:attrName>style.visibility</p:attrName>
-                                  </p:attrNameLst>
-                                </p:cBhvr>
-                                <p:to>
-                                  <p:strVal val="visible"/>
-                                </p:to>
-                              </p:set>
-                              <p:set>
-                                <p:cBhvr>
-                                  <p:cTn id="16" dur="1" fill="hold">
-                                    <p:stCondLst>
-                                      <p:cond delay="0"/>
-                                    </p:stCondLst>
-                                  </p:cTn>
-                                  <p:tgtEl>
-                                    <p:spTgt spid="32"/>
-                                  </p:tgtEl>
-                                  <p:attrNameLst>
-                                    <p:attrName>style.visibility</p:attrName>
-                                  </p:attrNameLst>
-                                </p:cBhvr>
-                                <p:to>
-                                  <p:strVal val="visible"/>
-                                </p:to>
-                              </p:set>
-                              <p:set>
-                                <p:cBhvr>
-                                  <p:cTn id="17" dur="1" fill="hold">
-                                    <p:stCondLst>
-                                      <p:cond delay="0"/>
-                                    </p:stCondLst>
-                                  </p:cTn>
-                                  <p:tgtEl>
-                                    <p:spTgt spid="33"/>
-                                  </p:tgtEl>
-                                  <p:attrNameLst>
-                                    <p:attrName>style.visibility</p:attrName>
-                                  </p:attrNameLst>
-                                </p:cBhvr>
-                                <p:to>
-                                  <p:strVal val="visible"/>
-                                </p:to>
-                              </p:set>
-                              <p:set>
-                                <p:cBhvr>
-                                  <p:cTn id="18" dur="1" fill="hold">
-                                    <p:stCondLst>
-                                      <p:cond delay="0"/>
-                                    </p:stCondLst>
-                                  </p:cTn>
-                                  <p:tgtEl>
-                                    <p:spTgt spid="34"/>
-                                  </p:tgtEl>
-                                  <p:attrNameLst>
-                                    <p:attrName>style.visibility</p:attrName>
-                                  </p:attrNameLst>
-                                </p:cBhvr>
-                                <p:to>
-                                  <p:strVal val="visible"/>
-                                </p:to>
-                              </p:set>
-                              <p:set>
-                                <p:cBhvr>
-                                  <p:cTn id="19" dur="1" fill="hold">
-                                    <p:stCondLst>
-                                      <p:cond delay="0"/>
-                                    </p:stCondLst>
-                                  </p:cTn>
-                                  <p:tgtEl>
-                                    <p:spTgt spid="35"/>
-                                  </p:tgtEl>
-                                  <p:attrNameLst>
-                                    <p:attrName>style.visibility</p:attrName>
-                                  </p:attrNameLst>
-                                </p:cBhvr>
-                                <p:to>
-                                  <p:strVal val="visible"/>
-                                </p:to>
-                              </p:set>
+                              <p:par>
+                                <p:cTn id="5" presetID="2" presetClass="entr" presetSubtype="0" fill="hold" grpId="0" nodeType="clickEffect">
+                                  <p:stCondLst>
+                                    <p:cond delay="0"/>
+                                  </p:stCondLst>
+                                  <p:childTnLst>
+                                    <p:set>
+                                      <p:cBhvr>
+                                        <p:cTn id="6" dur="1" fill="hold">
+                                          <p:stCondLst>
+                                            <p:cond delay="0"/>
+                                          </p:stCondLst>
+                                        </p:cTn>
+                                        <p:tgtEl>
+                                          <p:spTgt spid="21"/>
+                                        </p:tgtEl>
+                                        <p:attrNameLst>
+                                          <p:attrName>style.visibility</p:attrName>
+                                        </p:attrNameLst>
+                                      </p:cBhvr>
+                                      <p:to>
+                                        <p:strVal val="visible"/>
+                                      </p:to>
+                                    </p:set>
+                                    <p:set>
+                                      <p:cBhvr>
+                                        <p:cTn id="7" dur="1" fill="hold">
+                                          <p:stCondLst>
+                                            <p:cond delay="0"/>
+                                          </p:stCondLst>
+                                        </p:cTn>
+                                        <p:tgtEl>
+                                          <p:spTgt spid="22"/>
+                                        </p:tgtEl>
+                                        <p:attrNameLst>
+                                          <p:attrName>style.visibility</p:attrName>
+                                        </p:attrNameLst>
+                                      </p:cBhvr>
+                                      <p:to>
+                                        <p:strVal val="visible"/>
+                                      </p:to>
+                                    </p:set>
+                                    <p:set>
+                                      <p:cBhvr>
+                                        <p:cTn id="8" dur="1" fill="hold">
+                                          <p:stCondLst>
+                                            <p:cond delay="0"/>
+                                          </p:stCondLst>
+                                        </p:cTn>
+                                        <p:tgtEl>
+                                          <p:spTgt spid="23"/>
+                                        </p:tgtEl>
+                                        <p:attrNameLst>
+                                          <p:attrName>style.visibility</p:attrName>
+                                        </p:attrNameLst>
+                                      </p:cBhvr>
+                                      <p:to>
+                                        <p:strVal val="visible"/>
+                                      </p:to>
+                                    </p:set>
+                                    <p:set>
+                                      <p:cBhvr>
+                                        <p:cTn id="9" dur="1" fill="hold">
+                                          <p:stCondLst>
+                                            <p:cond delay="0"/>
+                                          </p:stCondLst>
+                                        </p:cTn>
+                                        <p:tgtEl>
+                                          <p:spTgt spid="24"/>
+                                        </p:tgtEl>
+                                        <p:attrNameLst>
+                                          <p:attrName>style.visibility</p:attrName>
+                                        </p:attrNameLst>
+                                      </p:cBhvr>
+                                      <p:to>
+                                        <p:strVal val="visible"/>
+                                      </p:to>
+                                    </p:set>
+                                    <p:set>
+                                      <p:cBhvr>
+                                        <p:cTn id="10" dur="1" fill="hold">
+                                          <p:stCondLst>
+                                            <p:cond delay="0"/>
+                                          </p:stCondLst>
+                                        </p:cTn>
+                                        <p:tgtEl>
+                                          <p:spTgt spid="25"/>
+                                        </p:tgtEl>
+                                        <p:attrNameLst>
+                                          <p:attrName>style.visibility</p:attrName>
+                                        </p:attrNameLst>
+                                      </p:cBhvr>
+                                      <p:to>
+                                        <p:strVal val="visible"/>
+                                      </p:to>
+                                    </p:set>
+                                    <p:set>
+                                      <p:cBhvr>
+                                        <p:cTn id="11" dur="1" fill="hold">
+                                          <p:stCondLst>
+                                            <p:cond delay="0"/>
+                                          </p:stCondLst>
+                                        </p:cTn>
+                                        <p:tgtEl>
+                                          <p:spTgt spid="26"/>
+                                        </p:tgtEl>
+                                        <p:attrNameLst>
+                                          <p:attrName>style.visibility</p:attrName>
+                                        </p:attrNameLst>
+                                      </p:cBhvr>
+                                      <p:to>
+                                        <p:strVal val="visible"/>
+                                      </p:to>
+                                    </p:set>
+                                    <p:set>
+                                      <p:cBhvr>
+                                        <p:cTn id="12" dur="1" fill="hold">
+                                          <p:stCondLst>
+                                            <p:cond delay="0"/>
+                                          </p:stCondLst>
+                                        </p:cTn>
+                                        <p:tgtEl>
+                                          <p:spTgt spid="27"/>
+                                        </p:tgtEl>
+                                        <p:attrNameLst>
+                                          <p:attrName>style.visibility</p:attrName>
+                                        </p:attrNameLst>
+                                      </p:cBhvr>
+                                      <p:to>
+                                        <p:strVal val="visible"/>
+                                      </p:to>
+                                    </p:set>
+                                    <p:set>
+                                      <p:cBhvr>
+                                        <p:cTn id="13" dur="1" fill="hold">
+                                          <p:stCondLst>
+                                            <p:cond delay="0"/>
+                                          </p:stCondLst>
+                                        </p:cTn>
+                                        <p:tgtEl>
+                                          <p:spTgt spid="28"/>
+                                        </p:tgtEl>
+                                        <p:attrNameLst>
+                                          <p:attrName>style.visibility</p:attrName>
+                                        </p:attrNameLst>
+                                      </p:cBhvr>
+                                      <p:to>
+                                        <p:strVal val="visible"/>
+                                      </p:to>
+                                    </p:set>
+                                    <p:set>
+                                      <p:cBhvr>
+                                        <p:cTn id="14" dur="1" fill="hold">
+                                          <p:stCondLst>
+                                            <p:cond delay="0"/>
+                                          </p:stCondLst>
+                                        </p:cTn>
+                                        <p:tgtEl>
+                                          <p:spTgt spid="29"/>
+                                        </p:tgtEl>
+                                        <p:attrNameLst>
+                                          <p:attrName>style.visibility</p:attrName>
+                                        </p:attrNameLst>
+                                      </p:cBhvr>
+                                      <p:to>
+                                        <p:strVal val="visible"/>
+                                      </p:to>
+                                    </p:set>
+                                    <p:set>
+                                      <p:cBhvr>
+                                        <p:cTn id="15" dur="1" fill="hold">
+                                          <p:stCondLst>
+                                            <p:cond delay="0"/>
+                                          </p:stCondLst>
+                                        </p:cTn>
+                                        <p:tgtEl>
+                                          <p:spTgt spid="30"/>
+                                        </p:tgtEl>
+                                        <p:attrNameLst>
+                                          <p:attrName>style.visibility</p:attrName>
+                                        </p:attrNameLst>
+                                      </p:cBhvr>
+                                      <p:to>
+                                        <p:strVal val="visible"/>
+                                      </p:to>
+                                    </p:set>
+                                    <p:set>
+                                      <p:cBhvr>
+                                        <p:cTn id="16" dur="1" fill="hold">
+                                          <p:stCondLst>
+                                            <p:cond delay="0"/>
+                                          </p:stCondLst>
+                                        </p:cTn>
+                                        <p:tgtEl>
+                                          <p:spTgt spid="31"/>
+                                        </p:tgtEl>
+                                        <p:attrNameLst>
+                                          <p:attrName>style.visibility</p:attrName>
+                                        </p:attrNameLst>
+                                      </p:cBhvr>
+                                      <p:to>
+                                        <p:strVal val="visible"/>
+                                      </p:to>
+                                    </p:set>
+                                    <p:set>
+                                      <p:cBhvr>
+                                        <p:cTn id="17" dur="1" fill="hold">
+                                          <p:stCondLst>
+                                            <p:cond delay="0"/>
+                                          </p:stCondLst>
+                                        </p:cTn>
+                                        <p:tgtEl>
+                                          <p:spTgt spid="32"/>
+                                        </p:tgtEl>
+                                        <p:attrNameLst>
+                                          <p:attrName>style.visibility</p:attrName>
+                                        </p:attrNameLst>
+                                      </p:cBhvr>
+                                      <p:to>
+                                        <p:strVal val="visible"/>
+                                      </p:to>
+                                    </p:set>
+                                    <p:set>
+                                      <p:cBhvr>
+                                        <p:cTn id="18" dur="1" fill="hold">
+                                          <p:stCondLst>
+                                            <p:cond delay="0"/>
+                                          </p:stCondLst>
+                                        </p:cTn>
+                                        <p:tgtEl>
+                                          <p:spTgt spid="33"/>
+                                        </p:tgtEl>
+                                        <p:attrNameLst>
+                                          <p:attrName>style.visibility</p:attrName>
+                                        </p:attrNameLst>
+                                      </p:cBhvr>
+                                      <p:to>
+                                        <p:strVal val="visible"/>
+                                      </p:to>
+                                    </p:set>
+                                    <p:set>
+                                      <p:cBhvr>
+                                        <p:cTn id="19" dur="1" fill="hold">
+                                          <p:stCondLst>
+                                            <p:cond delay="0"/>
+                                          </p:stCondLst>
+                                        </p:cTn>
+                                        <p:tgtEl>
+                                          <p:spTgt spid="34"/>
+                                        </p:tgtEl>
+                                        <p:attrNameLst>
+                                          <p:attrName>style.visibility</p:attrName>
+                                        </p:attrNameLst>
+                                      </p:cBhvr>
+                                      <p:to>
+                                        <p:strVal val="visible"/>
+                                      </p:to>
+                                    </p:set>
+                                    <p:set>
+                                      <p:cBhvr>
+                                        <p:cTn id="20" dur="1" fill="hold">
+                                          <p:stCondLst>
+                                            <p:cond delay="0"/>
+                                          </p:stCondLst>
+                                        </p:cTn>
+                                        <p:tgtEl>
+                                          <p:spTgt spid="35"/>
+                                        </p:tgtEl>
+                                        <p:attrNameLst>
+                                          <p:attrName>style.visibility</p:attrName>
+                                        </p:attrNameLst>
+                                      </p:cBhvr>
+                                      <p:to>
+                                        <p:strVal val="visible"/>
+                                      </p:to>
+                                    </p:set>
+                                  </p:childTnLst>
+                                </p:cTn>
+                              </p:par>
                             </p:childTnLst>
                           </p:cTn>
                         </p:par>
@@ -24121,6 +24245,20 @@
                   </p:par>
                 </p:childTnLst>
               </p:cTn>
+              <p:prevCondLst>
+                <p:cond evt="onPrev" delay="0">
+                  <p:tgtEl>
+                    <p:sldTgt/>
+                  </p:tgtEl>
+                </p:cond>
+              </p:prevCondLst>
+              <p:nextCondLst>
+                <p:cond evt="onNext" delay="0">
+                  <p:tgtEl>
+                    <p:sldTgt/>
+                  </p:tgtEl>
+                </p:cond>
+              </p:nextCondLst>
             </p:seq>
           </p:childTnLst>
         </p:cTn>
@@ -34249,209 +34387,218 @@
                       </p:stCondLst>
                       <p:childTnLst>
                         <p:par>
-                          <p:cTn id="4" presetID="2" presetClass="entr" presetSubtype="0" fill="hold" nodeType="clickEffect">
+                          <p:cTn id="4" fill="hold">
                             <p:stCondLst>
                               <p:cond delay="0"/>
                             </p:stCondLst>
                             <p:childTnLst>
-                              <p:set>
-                                <p:cBhvr>
-                                  <p:cTn id="5" dur="1" fill="hold">
-                                    <p:stCondLst>
-                                      <p:cond delay="0"/>
-                                    </p:stCondLst>
-                                  </p:cTn>
-                                  <p:tgtEl>
-                                    <p:spTgt spid="23"/>
-                                  </p:tgtEl>
-                                  <p:attrNameLst>
-                                    <p:attrName>style.visibility</p:attrName>
-                                  </p:attrNameLst>
-                                </p:cBhvr>
-                                <p:to>
-                                  <p:strVal val="visible"/>
-                                </p:to>
-                              </p:set>
-                              <p:set>
-                                <p:cBhvr>
-                                  <p:cTn id="6" dur="1" fill="hold">
-                                    <p:stCondLst>
-                                      <p:cond delay="0"/>
-                                    </p:stCondLst>
-                                  </p:cTn>
-                                  <p:tgtEl>
-                                    <p:spTgt spid="24"/>
-                                  </p:tgtEl>
-                                  <p:attrNameLst>
-                                    <p:attrName>style.visibility</p:attrName>
-                                  </p:attrNameLst>
-                                </p:cBhvr>
-                                <p:to>
-                                  <p:strVal val="visible"/>
-                                </p:to>
-                              </p:set>
-                              <p:set>
-                                <p:cBhvr>
-                                  <p:cTn id="7" dur="1" fill="hold">
-                                    <p:stCondLst>
-                                      <p:cond delay="0"/>
-                                    </p:stCondLst>
-                                  </p:cTn>
-                                  <p:tgtEl>
-                                    <p:spTgt spid="25"/>
-                                  </p:tgtEl>
-                                  <p:attrNameLst>
-                                    <p:attrName>style.visibility</p:attrName>
-                                  </p:attrNameLst>
-                                </p:cBhvr>
-                                <p:to>
-                                  <p:strVal val="visible"/>
-                                </p:to>
-                              </p:set>
-                              <p:set>
-                                <p:cBhvr>
-                                  <p:cTn id="8" dur="1" fill="hold">
-                                    <p:stCondLst>
-                                      <p:cond delay="0"/>
-                                    </p:stCondLst>
-                                  </p:cTn>
-                                  <p:tgtEl>
-                                    <p:spTgt spid="26"/>
-                                  </p:tgtEl>
-                                  <p:attrNameLst>
-                                    <p:attrName>style.visibility</p:attrName>
-                                  </p:attrNameLst>
-                                </p:cBhvr>
-                                <p:to>
-                                  <p:strVal val="visible"/>
-                                </p:to>
-                              </p:set>
-                              <p:set>
-                                <p:cBhvr>
-                                  <p:cTn id="9" dur="1" fill="hold">
-                                    <p:stCondLst>
-                                      <p:cond delay="0"/>
-                                    </p:stCondLst>
-                                  </p:cTn>
-                                  <p:tgtEl>
-                                    <p:spTgt spid="27"/>
-                                  </p:tgtEl>
-                                  <p:attrNameLst>
-                                    <p:attrName>style.visibility</p:attrName>
-                                  </p:attrNameLst>
-                                </p:cBhvr>
-                                <p:to>
-                                  <p:strVal val="visible"/>
-                                </p:to>
-                              </p:set>
-                              <p:set>
-                                <p:cBhvr>
-                                  <p:cTn id="10" dur="1" fill="hold">
-                                    <p:stCondLst>
-                                      <p:cond delay="0"/>
-                                    </p:stCondLst>
-                                  </p:cTn>
-                                  <p:tgtEl>
-                                    <p:spTgt spid="28"/>
-                                  </p:tgtEl>
-                                  <p:attrNameLst>
-                                    <p:attrName>style.visibility</p:attrName>
-                                  </p:attrNameLst>
-                                </p:cBhvr>
-                                <p:to>
-                                  <p:strVal val="visible"/>
-                                </p:to>
-                              </p:set>
-                              <p:set>
-                                <p:cBhvr>
-                                  <p:cTn id="11" dur="1" fill="hold">
-                                    <p:stCondLst>
-                                      <p:cond delay="0"/>
-                                    </p:stCondLst>
-                                  </p:cTn>
-                                  <p:tgtEl>
-                                    <p:spTgt spid="29"/>
-                                  </p:tgtEl>
-                                  <p:attrNameLst>
-                                    <p:attrName>style.visibility</p:attrName>
-                                  </p:attrNameLst>
-                                </p:cBhvr>
-                                <p:to>
-                                  <p:strVal val="visible"/>
-                                </p:to>
-                              </p:set>
-                              <p:set>
-                                <p:cBhvr>
-                                  <p:cTn id="12" dur="1" fill="hold">
-                                    <p:stCondLst>
-                                      <p:cond delay="0"/>
-                                    </p:stCondLst>
-                                  </p:cTn>
-                                  <p:tgtEl>
-                                    <p:spTgt spid="30"/>
-                                  </p:tgtEl>
-                                  <p:attrNameLst>
-                                    <p:attrName>style.visibility</p:attrName>
-                                  </p:attrNameLst>
-                                </p:cBhvr>
-                                <p:to>
-                                  <p:strVal val="visible"/>
-                                </p:to>
-                              </p:set>
-                              <p:set>
-                                <p:cBhvr>
-                                  <p:cTn id="13" dur="1" fill="hold">
-                                    <p:stCondLst>
-                                      <p:cond delay="0"/>
-                                    </p:stCondLst>
-                                  </p:cTn>
-                                  <p:tgtEl>
-                                    <p:spTgt spid="31"/>
-                                  </p:tgtEl>
-                                  <p:attrNameLst>
-                                    <p:attrName>style.visibility</p:attrName>
-                                  </p:attrNameLst>
-                                </p:cBhvr>
-                                <p:to>
-                                  <p:strVal val="visible"/>
-                                </p:to>
-                              </p:set>
-                              <p:set>
-                                <p:cBhvr>
-                                  <p:cTn id="14" dur="1" fill="hold">
-                                    <p:stCondLst>
-                                      <p:cond delay="0"/>
-                                    </p:stCondLst>
-                                  </p:cTn>
-                                  <p:tgtEl>
-                                    <p:spTgt spid="32"/>
-                                  </p:tgtEl>
-                                  <p:attrNameLst>
-                                    <p:attrName>style.visibility</p:attrName>
-                                  </p:attrNameLst>
-                                </p:cBhvr>
-                                <p:to>
-                                  <p:strVal val="visible"/>
-                                </p:to>
-                              </p:set>
-                              <p:set>
-                                <p:cBhvr>
-                                  <p:cTn id="15" dur="1" fill="hold">
-                                    <p:stCondLst>
-                                      <p:cond delay="0"/>
-                                    </p:stCondLst>
-                                  </p:cTn>
-                                  <p:tgtEl>
-                                    <p:spTgt spid="33"/>
-                                  </p:tgtEl>
-                                  <p:attrNameLst>
-                                    <p:attrName>style.visibility</p:attrName>
-                                  </p:attrNameLst>
-                                </p:cBhvr>
-                                <p:to>
-                                  <p:strVal val="visible"/>
-                                </p:to>
-                              </p:set>
+                              <p:par>
+                                <p:cTn id="5" presetID="2" presetClass="entr" presetSubtype="0" fill="hold" grpId="0" nodeType="clickEffect">
+                                  <p:stCondLst>
+                                    <p:cond delay="0"/>
+                                  </p:stCondLst>
+                                  <p:childTnLst>
+                                    <p:set>
+                                      <p:cBhvr>
+                                        <p:cTn id="6" dur="1" fill="hold">
+                                          <p:stCondLst>
+                                            <p:cond delay="0"/>
+                                          </p:stCondLst>
+                                        </p:cTn>
+                                        <p:tgtEl>
+                                          <p:spTgt spid="23"/>
+                                        </p:tgtEl>
+                                        <p:attrNameLst>
+                                          <p:attrName>style.visibility</p:attrName>
+                                        </p:attrNameLst>
+                                      </p:cBhvr>
+                                      <p:to>
+                                        <p:strVal val="visible"/>
+                                      </p:to>
+                                    </p:set>
+                                    <p:set>
+                                      <p:cBhvr>
+                                        <p:cTn id="7" dur="1" fill="hold">
+                                          <p:stCondLst>
+                                            <p:cond delay="0"/>
+                                          </p:stCondLst>
+                                        </p:cTn>
+                                        <p:tgtEl>
+                                          <p:spTgt spid="24"/>
+                                        </p:tgtEl>
+                                        <p:attrNameLst>
+                                          <p:attrName>style.visibility</p:attrName>
+                                        </p:attrNameLst>
+                                      </p:cBhvr>
+                                      <p:to>
+                                        <p:strVal val="visible"/>
+                                      </p:to>
+                                    </p:set>
+                                    <p:set>
+                                      <p:cBhvr>
+                                        <p:cTn id="8" dur="1" fill="hold">
+                                          <p:stCondLst>
+                                            <p:cond delay="0"/>
+                                          </p:stCondLst>
+                                        </p:cTn>
+                                        <p:tgtEl>
+                                          <p:spTgt spid="25"/>
+                                        </p:tgtEl>
+                                        <p:attrNameLst>
+                                          <p:attrName>style.visibility</p:attrName>
+                                        </p:attrNameLst>
+                                      </p:cBhvr>
+                                      <p:to>
+                                        <p:strVal val="visible"/>
+                                      </p:to>
+                                    </p:set>
+                                    <p:set>
+                                      <p:cBhvr>
+                                        <p:cTn id="9" dur="1" fill="hold">
+                                          <p:stCondLst>
+                                            <p:cond delay="0"/>
+                                          </p:stCondLst>
+                                        </p:cTn>
+                                        <p:tgtEl>
+                                          <p:spTgt spid="26"/>
+                                        </p:tgtEl>
+                                        <p:attrNameLst>
+                                          <p:attrName>style.visibility</p:attrName>
+                                        </p:attrNameLst>
+                                      </p:cBhvr>
+                                      <p:to>
+                                        <p:strVal val="visible"/>
+                                      </p:to>
+                                    </p:set>
+                                    <p:set>
+                                      <p:cBhvr>
+                                        <p:cTn id="10" dur="1" fill="hold">
+                                          <p:stCondLst>
+                                            <p:cond delay="0"/>
+                                          </p:stCondLst>
+                                        </p:cTn>
+                                        <p:tgtEl>
+                                          <p:spTgt spid="27"/>
+                                        </p:tgtEl>
+                                        <p:attrNameLst>
+                                          <p:attrName>style.visibility</p:attrName>
+                                        </p:attrNameLst>
+                                      </p:cBhvr>
+                                      <p:to>
+                                        <p:strVal val="visible"/>
+                                      </p:to>
+                                    </p:set>
+                                    <p:set>
+                                      <p:cBhvr>
+                                        <p:cTn id="11" dur="1" fill="hold">
+                                          <p:stCondLst>
+                                            <p:cond delay="0"/>
+                                          </p:stCondLst>
+                                        </p:cTn>
+                                        <p:tgtEl>
+                                          <p:spTgt spid="28"/>
+                                        </p:tgtEl>
+                                        <p:attrNameLst>
+                                          <p:attrName>style.visibility</p:attrName>
+                                        </p:attrNameLst>
+                                      </p:cBhvr>
+                                      <p:to>
+                                        <p:strVal val="visible"/>
+                                      </p:to>
+                                    </p:set>
+                                    <p:set>
+                                      <p:cBhvr>
+                                        <p:cTn id="12" dur="1" fill="hold">
+                                          <p:stCondLst>
+                                            <p:cond delay="0"/>
+                                          </p:stCondLst>
+                                        </p:cTn>
+                                        <p:tgtEl>
+                                          <p:spTgt spid="29"/>
+                                        </p:tgtEl>
+                                        <p:attrNameLst>
+                                          <p:attrName>style.visibility</p:attrName>
+                                        </p:attrNameLst>
+                                      </p:cBhvr>
+                                      <p:to>
+                                        <p:strVal val="visible"/>
+                                      </p:to>
+                                    </p:set>
+                                    <p:set>
+                                      <p:cBhvr>
+                                        <p:cTn id="13" dur="1" fill="hold">
+                                          <p:stCondLst>
+                                            <p:cond delay="0"/>
+                                          </p:stCondLst>
+                                        </p:cTn>
+                                        <p:tgtEl>
+                                          <p:spTgt spid="30"/>
+                                        </p:tgtEl>
+                                        <p:attrNameLst>
+                                          <p:attrName>style.visibility</p:attrName>
+                                        </p:attrNameLst>
+                                      </p:cBhvr>
+                                      <p:to>
+                                        <p:strVal val="visible"/>
+                                      </p:to>
+                                    </p:set>
+                                    <p:set>
+                                      <p:cBhvr>
+                                        <p:cTn id="14" dur="1" fill="hold">
+                                          <p:stCondLst>
+                                            <p:cond delay="0"/>
+                                          </p:stCondLst>
+                                        </p:cTn>
+                                        <p:tgtEl>
+                                          <p:spTgt spid="31"/>
+                                        </p:tgtEl>
+                                        <p:attrNameLst>
+                                          <p:attrName>style.visibility</p:attrName>
+                                        </p:attrNameLst>
+                                      </p:cBhvr>
+                                      <p:to>
+                                        <p:strVal val="visible"/>
+                                      </p:to>
+                                    </p:set>
+                                    <p:set>
+                                      <p:cBhvr>
+                                        <p:cTn id="15" dur="1" fill="hold">
+                                          <p:stCondLst>
+                                            <p:cond delay="0"/>
+                                          </p:stCondLst>
+                                        </p:cTn>
+                                        <p:tgtEl>
+                                          <p:spTgt spid="32"/>
+                                        </p:tgtEl>
+                                        <p:attrNameLst>
+                                          <p:attrName>style.visibility</p:attrName>
+                                        </p:attrNameLst>
+                                      </p:cBhvr>
+                                      <p:to>
+                                        <p:strVal val="visible"/>
+                                      </p:to>
+                                    </p:set>
+                                    <p:set>
+                                      <p:cBhvr>
+                                        <p:cTn id="16" dur="1" fill="hold">
+                                          <p:stCondLst>
+                                            <p:cond delay="0"/>
+                                          </p:stCondLst>
+                                        </p:cTn>
+                                        <p:tgtEl>
+                                          <p:spTgt spid="33"/>
+                                        </p:tgtEl>
+                                        <p:attrNameLst>
+                                          <p:attrName>style.visibility</p:attrName>
+                                        </p:attrNameLst>
+                                      </p:cBhvr>
+                                      <p:to>
+                                        <p:strVal val="visible"/>
+                                      </p:to>
+                                    </p:set>
+                                  </p:childTnLst>
+                                </p:cTn>
+                              </p:par>
                             </p:childTnLst>
                           </p:cTn>
                         </p:par>
@@ -34460,6 +34607,20 @@
                   </p:par>
                 </p:childTnLst>
               </p:cTn>
+              <p:prevCondLst>
+                <p:cond evt="onPrev" delay="0">
+                  <p:tgtEl>
+                    <p:sldTgt/>
+                  </p:tgtEl>
+                </p:cond>
+              </p:prevCondLst>
+              <p:nextCondLst>
+                <p:cond evt="onNext" delay="0">
+                  <p:tgtEl>
+                    <p:sldTgt/>
+                  </p:tgtEl>
+                </p:cond>
+              </p:nextCondLst>
             </p:seq>
           </p:childTnLst>
         </p:cTn>

</xml_diff>